<commit_message>
Fix IFoA reference pptx: add title/subtitle placeholders so title and section slides render
Co-Authored-By: Claude Fable 5 <noreply@anthropic.com>
</commit_message>
<xml_diff>
--- a/presentations/ifoa/hwle_ifoa_life_2026.pptx
+++ b/presentations/ifoa/hwle_ifoa_life_2026.pptx
@@ -1016,13 +1016,13 @@
             <a:spLocks noGrp="1"/>
           </p:cNvSpPr>
           <p:nvPr>
-            <p:ph type="title" hasCustomPrompt="1"/>
-          </p:nvPr>
-        </p:nvSpPr>
-        <p:spPr>
-          <a:xfrm>
-            <a:off x="4186804" y="3896206"/>
-            <a:ext cx="7882392" cy="1836584"/>
+            <p:ph type="ctrTitle" hasCustomPrompt="1"/>
+          </p:nvPr>
+        </p:nvSpPr>
+        <p:spPr>
+          <a:xfrm>
+            <a:off x="2500000" y="3200000"/>
+            <a:ext cx="11256000" cy="2000000"/>
           </a:xfrm>
           <a:prstGeom prst="rect">
             <a:avLst/>
@@ -1037,7 +1037,7 @@
               <a:lnSpc>
                 <a:spcPct val="90000"/>
               </a:lnSpc>
-              <a:defRPr sz="7000" b="1" i="0">
+              <a:defRPr sz="4000" b="1" i="0">
                 <a:solidFill>
                   <a:schemeClr val="bg1"/>
                 </a:solidFill>
@@ -1059,6 +1059,57 @@
               <a:t>Conference 2026</a:t>
             </a:r>
             <a:endParaRPr lang="en-GB" dirty="0"/>
+          </a:p>
+        </p:txBody>
+      </p:sp>
+      <p:sp>
+        <p:nvSpPr>
+          <p:cNvPr id="70" name="Subtitle 2">
+            <a:extLst>
+              <a:ext uri="{FF2B5EF4-FFF2-40B4-BE49-F238E27FC236}">
+                <a16:creationId xmlns:a16="http://schemas.microsoft.com/office/drawing/2014/main" id="{6AA7276D-7192-0B34-473D-EA39E90AE911}"/>
+              </a:ext>
+            </a:extLst>
+          </p:cNvPr>
+          <p:cNvSpPr>
+            <a:spLocks noGrp="1"/>
+          </p:cNvSpPr>
+          <p:nvPr>
+            <p:ph type="subTitle" idx="1"/>
+          </p:nvPr>
+        </p:nvSpPr>
+        <p:spPr>
+          <a:xfrm>
+            <a:off x="2500000" y="5300000"/>
+            <a:ext cx="11256000" cy="2400000"/>
+          </a:xfrm>
+          <a:prstGeom prst="rect">
+            <a:avLst/>
+          </a:prstGeom>
+        </p:spPr>
+        <p:txBody>
+          <a:bodyPr vert="horz" lIns="91440" tIns="45720" rIns="91440" bIns="45720" rtlCol="0" anchor="t">
+            <a:noAutofit/>
+          </a:bodyPr>
+          <a:lstStyle>
+            <a:lvl1pPr algn="ctr">
+              <a:lnSpc>
+                <a:spcPct val="90000"/>
+              </a:lnSpc>
+              <a:defRPr sz="1800" b="0" i="0">
+                <a:solidFill>
+                  <a:schemeClr val="bg1"/>
+                </a:solidFill>
+                <a:latin typeface="Arial" panose="020B0604020202020204" pitchFamily="34" charset="0"/>
+                <a:cs typeface="Arial" panose="020B0604020202020204" pitchFamily="34" charset="0"/>
+              </a:defRPr>
+            </a:lvl1pPr>
+          </a:lstStyle>
+          <a:p>
+            <a:r>
+              <a:rPr lang="en-GB"/>
+              <a:t>Subtitle</a:t>
+            </a:r>
           </a:p>
         </p:txBody>
       </p:sp>
@@ -7612,6 +7663,46 @@
           </a:fontRef>
         </p:style>
       </p:cxnSp>
+      <p:sp>
+        <p:nvSpPr>
+          <p:cNvPr id="914" name="Title 1">
+            <a:extLst>
+              <a:ext uri="{FF2B5EF4-FFF2-40B4-BE49-F238E27FC236}">
+                <a16:creationId xmlns:a16="http://schemas.microsoft.com/office/drawing/2014/main" id="{EF499182-B1CD-4399-99FD-7B1CA914FD59}"/>
+              </a:ext>
+            </a:extLst>
+          </p:cNvPr>
+          <p:cNvSpPr>
+            <a:spLocks noGrp="1"/>
+          </p:cNvSpPr>
+          <p:nvPr>
+            <p:ph type="title" hasCustomPrompt="1"/>
+          </p:nvPr>
+        </p:nvSpPr>
+        <p:spPr>
+          <a:xfrm>
+            <a:off x="1500000" y="3400000"/>
+            <a:ext cx="13256000" cy="2200000"/>
+          </a:xfrm>
+        </p:spPr>
+        <p:txBody>
+          <a:bodyPr>
+            <a:normAutofit/>
+          </a:bodyPr>
+          <a:lstStyle>
+            <a:lvl1pPr>
+              <a:defRPr sz="4400" cap="none" baseline="0"/>
+            </a:lvl1pPr>
+          </a:lstStyle>
+          <a:p>
+            <a:r>
+              <a:rPr lang="en-US" dirty="0"/>
+              <a:t>Title</a:t>
+            </a:r>
+            <a:endParaRPr lang="en-GB" dirty="0"/>
+          </a:p>
+        </p:txBody>
+      </p:sp>
     </p:spTree>
     <p:extLst>
       <p:ext uri="{BB962C8B-B14F-4D97-AF65-F5344CB8AC3E}">
@@ -11248,8 +11339,100 @@
           <a:chExt cx="0" cy="0"/>
         </a:xfrm>
       </p:grpSpPr>
-      <p:sp/>
-      <p:sp/>
+      <p:sp>
+        <p:nvSpPr>
+          <p:cNvPr id="7" name="Title Placeholder 1">
+            <a:extLst>
+              <a:ext uri="{FF2B5EF4-FFF2-40B4-BE49-F238E27FC236}">
+                <a16:creationId xmlns:a16="http://schemas.microsoft.com/office/drawing/2014/main" id="{6AA7276D-7192-0B34-473D-EA39E90AE910}"/>
+              </a:ext>
+            </a:extLst>
+          </p:cNvPr>
+          <p:cNvSpPr>
+            <a:spLocks noGrp="1"/>
+          </p:cNvSpPr>
+          <p:nvPr>
+            <p:ph hasCustomPrompt="1" type="ctrTitle"/>
+          </p:nvPr>
+        </p:nvSpPr>
+        <p:spPr>
+          <a:xfrm>
+            <a:off x="2500000" y="3200000"/>
+            <a:ext cx="11256000" cy="2000000"/>
+          </a:xfrm>
+          <a:prstGeom prst="rect">
+            <a:avLst/>
+          </a:prstGeom>
+        </p:spPr>
+        <p:txBody>
+          <a:bodyPr/>
+          <a:lstStyle/>
+          <a:p>
+            <a:pPr lvl="0" indent="0" marL="0">
+              <a:buNone/>
+            </a:pPr>
+            <a:r>
+              <a:rPr/>
+              <a:t>Healthy Working Life Expectancy</a:t>
+            </a:r>
+          </a:p>
+        </p:txBody>
+      </p:sp>
+      <p:sp>
+        <p:nvSpPr>
+          <p:cNvPr id="70" name="Subtitle 2">
+            <a:extLst>
+              <a:ext uri="{FF2B5EF4-FFF2-40B4-BE49-F238E27FC236}">
+                <a16:creationId xmlns:a16="http://schemas.microsoft.com/office/drawing/2014/main" id="{6AA7276D-7192-0B34-473D-EA39E90AE911}"/>
+              </a:ext>
+            </a:extLst>
+          </p:cNvPr>
+          <p:cNvSpPr>
+            <a:spLocks noGrp="1"/>
+          </p:cNvSpPr>
+          <p:nvPr>
+            <p:ph idx="1" type="subTitle"/>
+          </p:nvPr>
+        </p:nvSpPr>
+        <p:spPr>
+          <a:xfrm>
+            <a:off x="2500000" y="5300000"/>
+            <a:ext cx="11256000" cy="2400000"/>
+          </a:xfrm>
+          <a:prstGeom prst="rect">
+            <a:avLst/>
+          </a:prstGeom>
+        </p:spPr>
+        <p:txBody>
+          <a:bodyPr/>
+          <a:lstStyle/>
+          <a:p>
+            <a:pPr lvl="0" indent="0" marL="0">
+              <a:buNone/>
+            </a:pPr>
+            <a:r>
+              <a:rPr/>
+              <a:t>From survey data to insurer administrative data</a:t>
+            </a:r>
+            <a:br/>
+            <a:br/>
+            <a:r>
+              <a:rPr/>
+              <a:t>IFoA Healthy Workforce Working Party</a:t>
+            </a:r>
+            <a:br/>
+            <a:r>
+              <a:rPr/>
+              <a:t>Presented by David Beddows, Chris Martin and Jon Minton</a:t>
+            </a:r>
+            <a:br/>
+            <a:r>
+              <a:rPr/>
+              <a:t>on behalf of Z. Woodroffe, D. Bates, S. Batrakova, R. Pal and C. Zhang</a:t>
+            </a:r>
+          </a:p>
+        </p:txBody>
+      </p:sp>
       <p:sp/>
       <p:sp>
         <p:nvSpPr>
@@ -11369,7 +11552,42 @@
           <a:chExt cx="0" cy="0"/>
         </a:xfrm>
       </p:grpSpPr>
-      <p:sp/>
+      <p:sp>
+        <p:nvSpPr>
+          <p:cNvPr id="914" name="Title 1">
+            <a:extLst>
+              <a:ext uri="{FF2B5EF4-FFF2-40B4-BE49-F238E27FC236}">
+                <a16:creationId xmlns:a16="http://schemas.microsoft.com/office/drawing/2014/main" id="{EF499182-B1CD-4399-99FD-7B1CA914FD59}"/>
+              </a:ext>
+            </a:extLst>
+          </p:cNvPr>
+          <p:cNvSpPr>
+            <a:spLocks noGrp="1"/>
+          </p:cNvSpPr>
+          <p:nvPr>
+            <p:ph hasCustomPrompt="1" type="title"/>
+          </p:nvPr>
+        </p:nvSpPr>
+        <p:spPr>
+          <a:xfrm>
+            <a:off x="1500000" y="3400000"/>
+            <a:ext cx="13256000" cy="2200000"/>
+          </a:xfrm>
+        </p:spPr>
+        <p:txBody>
+          <a:bodyPr/>
+          <a:lstStyle/>
+          <a:p>
+            <a:pPr lvl="0" indent="0" marL="0">
+              <a:buNone/>
+            </a:pPr>
+            <a:r>
+              <a:rPr/>
+              <a:t>Why this matters [CHRIS · 10 min]</a:t>
+            </a:r>
+          </a:p>
+        </p:txBody>
+      </p:sp>
       <p:sp>
         <p:nvSpPr>
           <p:cNvPr id="8" name="Footer Placeholder 4">
@@ -12150,7 +12368,42 @@
           <a:chExt cx="0" cy="0"/>
         </a:xfrm>
       </p:grpSpPr>
-      <p:sp/>
+      <p:sp>
+        <p:nvSpPr>
+          <p:cNvPr id="914" name="Title 1">
+            <a:extLst>
+              <a:ext uri="{FF2B5EF4-FFF2-40B4-BE49-F238E27FC236}">
+                <a16:creationId xmlns:a16="http://schemas.microsoft.com/office/drawing/2014/main" id="{EF499182-B1CD-4399-99FD-7B1CA914FD59}"/>
+              </a:ext>
+            </a:extLst>
+          </p:cNvPr>
+          <p:cNvSpPr>
+            <a:spLocks noGrp="1"/>
+          </p:cNvSpPr>
+          <p:nvPr>
+            <p:ph hasCustomPrompt="1" type="title"/>
+          </p:nvPr>
+        </p:nvSpPr>
+        <p:spPr>
+          <a:xfrm>
+            <a:off x="1500000" y="3400000"/>
+            <a:ext cx="13256000" cy="2200000"/>
+          </a:xfrm>
+        </p:spPr>
+        <p:txBody>
+          <a:bodyPr/>
+          <a:lstStyle/>
+          <a:p>
+            <a:pPr lvl="0" indent="0" marL="0">
+              <a:buNone/>
+            </a:pPr>
+            <a:r>
+              <a:rPr/>
+              <a:t>Public health approaches with survey data [JON · 5–10 min]</a:t>
+            </a:r>
+          </a:p>
+        </p:txBody>
+      </p:sp>
       <p:sp>
         <p:nvSpPr>
           <p:cNvPr id="8" name="Footer Placeholder 4">
@@ -13443,7 +13696,42 @@
           <a:chExt cx="0" cy="0"/>
         </a:xfrm>
       </p:grpSpPr>
-      <p:sp/>
+      <p:sp>
+        <p:nvSpPr>
+          <p:cNvPr id="914" name="Title 1">
+            <a:extLst>
+              <a:ext uri="{FF2B5EF4-FFF2-40B4-BE49-F238E27FC236}">
+                <a16:creationId xmlns:a16="http://schemas.microsoft.com/office/drawing/2014/main" id="{EF499182-B1CD-4399-99FD-7B1CA914FD59}"/>
+              </a:ext>
+            </a:extLst>
+          </p:cNvPr>
+          <p:cNvSpPr>
+            <a:spLocks noGrp="1"/>
+          </p:cNvSpPr>
+          <p:nvPr>
+            <p:ph hasCustomPrompt="1" type="title"/>
+          </p:nvPr>
+        </p:nvSpPr>
+        <p:spPr>
+          <a:xfrm>
+            <a:off x="1500000" y="3400000"/>
+            <a:ext cx="13256000" cy="2200000"/>
+          </a:xfrm>
+        </p:spPr>
+        <p:txBody>
+          <a:bodyPr/>
+          <a:lstStyle/>
+          <a:p>
+            <a:pPr lvl="0" indent="0" marL="0">
+              <a:buNone/>
+            </a:pPr>
+            <a:r>
+              <a:rPr/>
+              <a:t>❓ Presentation-wide questions (REMOVE THIS SECTION BEFORE FINALISING)</a:t>
+            </a:r>
+          </a:p>
+        </p:txBody>
+      </p:sp>
       <p:sp>
         <p:nvSpPr>
           <p:cNvPr id="8" name="Footer Placeholder 4">
@@ -13788,7 +14076,42 @@
           <a:chExt cx="0" cy="0"/>
         </a:xfrm>
       </p:grpSpPr>
-      <p:sp/>
+      <p:sp>
+        <p:nvSpPr>
+          <p:cNvPr id="914" name="Title 1">
+            <a:extLst>
+              <a:ext uri="{FF2B5EF4-FFF2-40B4-BE49-F238E27FC236}">
+                <a16:creationId xmlns:a16="http://schemas.microsoft.com/office/drawing/2014/main" id="{EF499182-B1CD-4399-99FD-7B1CA914FD59}"/>
+              </a:ext>
+            </a:extLst>
+          </p:cNvPr>
+          <p:cNvSpPr>
+            <a:spLocks noGrp="1"/>
+          </p:cNvSpPr>
+          <p:nvPr>
+            <p:ph hasCustomPrompt="1" type="title"/>
+          </p:nvPr>
+        </p:nvSpPr>
+        <p:spPr>
+          <a:xfrm>
+            <a:off x="1500000" y="3400000"/>
+            <a:ext cx="13256000" cy="2200000"/>
+          </a:xfrm>
+        </p:spPr>
+        <p:txBody>
+          <a:bodyPr/>
+          <a:lstStyle/>
+          <a:p>
+            <a:pPr lvl="0" indent="0" marL="0">
+              <a:buNone/>
+            </a:pPr>
+            <a:r>
+              <a:rPr/>
+              <a:t>HWLE estimates with CMI rates [DAVID · 10 min]</a:t>
+            </a:r>
+          </a:p>
+        </p:txBody>
+      </p:sp>
       <p:sp>
         <p:nvSpPr>
           <p:cNvPr id="8" name="Footer Placeholder 4">
@@ -17112,7 +17435,42 @@
           <a:chExt cx="0" cy="0"/>
         </a:xfrm>
       </p:grpSpPr>
-      <p:sp/>
+      <p:sp>
+        <p:nvSpPr>
+          <p:cNvPr id="914" name="Title 1">
+            <a:extLst>
+              <a:ext uri="{FF2B5EF4-FFF2-40B4-BE49-F238E27FC236}">
+                <a16:creationId xmlns:a16="http://schemas.microsoft.com/office/drawing/2014/main" id="{EF499182-B1CD-4399-99FD-7B1CA914FD59}"/>
+              </a:ext>
+            </a:extLst>
+          </p:cNvPr>
+          <p:cNvSpPr>
+            <a:spLocks noGrp="1"/>
+          </p:cNvSpPr>
+          <p:nvPr>
+            <p:ph hasCustomPrompt="1" type="title"/>
+          </p:nvPr>
+        </p:nvSpPr>
+        <p:spPr>
+          <a:xfrm>
+            <a:off x="1500000" y="3400000"/>
+            <a:ext cx="13256000" cy="2200000"/>
+          </a:xfrm>
+        </p:spPr>
+        <p:txBody>
+          <a:bodyPr/>
+          <a:lstStyle/>
+          <a:p>
+            <a:pPr lvl="0" indent="0" marL="0">
+              <a:buNone/>
+            </a:pPr>
+            <a:r>
+              <a:rPr/>
+              <a:t>SUPPLEMENT — material held back from the main deck</a:t>
+            </a:r>
+          </a:p>
+        </p:txBody>
+      </p:sp>
       <p:sp>
         <p:nvSpPr>
           <p:cNvPr id="8" name="Footer Placeholder 4">
@@ -17448,7 +17806,42 @@
           <a:chExt cx="0" cy="0"/>
         </a:xfrm>
       </p:grpSpPr>
-      <p:sp/>
+      <p:sp>
+        <p:nvSpPr>
+          <p:cNvPr id="914" name="Title 1">
+            <a:extLst>
+              <a:ext uri="{FF2B5EF4-FFF2-40B4-BE49-F238E27FC236}">
+                <a16:creationId xmlns:a16="http://schemas.microsoft.com/office/drawing/2014/main" id="{EF499182-B1CD-4399-99FD-7B1CA914FD59}"/>
+              </a:ext>
+            </a:extLst>
+          </p:cNvPr>
+          <p:cNvSpPr>
+            <a:spLocks noGrp="1"/>
+          </p:cNvSpPr>
+          <p:nvPr>
+            <p:ph hasCustomPrompt="1" type="title"/>
+          </p:nvPr>
+        </p:nvSpPr>
+        <p:spPr>
+          <a:xfrm>
+            <a:off x="1500000" y="3400000"/>
+            <a:ext cx="13256000" cy="2200000"/>
+          </a:xfrm>
+        </p:spPr>
+        <p:txBody>
+          <a:bodyPr/>
+          <a:lstStyle/>
+          <a:p>
+            <a:pPr lvl="0" indent="0" marL="0">
+              <a:buNone/>
+            </a:pPr>
+            <a:r>
+              <a:rPr/>
+              <a:t>Supplement · Why this matters</a:t>
+            </a:r>
+          </a:p>
+        </p:txBody>
+      </p:sp>
       <p:sp>
         <p:nvSpPr>
           <p:cNvPr id="8" name="Footer Placeholder 4">
@@ -18504,7 +18897,42 @@
           <a:chExt cx="0" cy="0"/>
         </a:xfrm>
       </p:grpSpPr>
-      <p:sp/>
+      <p:sp>
+        <p:nvSpPr>
+          <p:cNvPr id="914" name="Title 1">
+            <a:extLst>
+              <a:ext uri="{FF2B5EF4-FFF2-40B4-BE49-F238E27FC236}">
+                <a16:creationId xmlns:a16="http://schemas.microsoft.com/office/drawing/2014/main" id="{EF499182-B1CD-4399-99FD-7B1CA914FD59}"/>
+              </a:ext>
+            </a:extLst>
+          </p:cNvPr>
+          <p:cNvSpPr>
+            <a:spLocks noGrp="1"/>
+          </p:cNvSpPr>
+          <p:nvPr>
+            <p:ph hasCustomPrompt="1" type="title"/>
+          </p:nvPr>
+        </p:nvSpPr>
+        <p:spPr>
+          <a:xfrm>
+            <a:off x="1500000" y="3400000"/>
+            <a:ext cx="13256000" cy="2200000"/>
+          </a:xfrm>
+        </p:spPr>
+        <p:txBody>
+          <a:bodyPr/>
+          <a:lstStyle/>
+          <a:p>
+            <a:pPr lvl="0" indent="0" marL="0">
+              <a:buNone/>
+            </a:pPr>
+            <a:r>
+              <a:rPr/>
+              <a:t>Supplement · Survey approaches</a:t>
+            </a:r>
+          </a:p>
+        </p:txBody>
+      </p:sp>
       <p:sp>
         <p:nvSpPr>
           <p:cNvPr id="8" name="Footer Placeholder 4">
@@ -19575,7 +20003,42 @@
           <a:chExt cx="0" cy="0"/>
         </a:xfrm>
       </p:grpSpPr>
-      <p:sp/>
+      <p:sp>
+        <p:nvSpPr>
+          <p:cNvPr id="914" name="Title 1">
+            <a:extLst>
+              <a:ext uri="{FF2B5EF4-FFF2-40B4-BE49-F238E27FC236}">
+                <a16:creationId xmlns:a16="http://schemas.microsoft.com/office/drawing/2014/main" id="{EF499182-B1CD-4399-99FD-7B1CA914FD59}"/>
+              </a:ext>
+            </a:extLst>
+          </p:cNvPr>
+          <p:cNvSpPr>
+            <a:spLocks noGrp="1"/>
+          </p:cNvSpPr>
+          <p:nvPr>
+            <p:ph hasCustomPrompt="1" type="title"/>
+          </p:nvPr>
+        </p:nvSpPr>
+        <p:spPr>
+          <a:xfrm>
+            <a:off x="1500000" y="3400000"/>
+            <a:ext cx="13256000" cy="2200000"/>
+          </a:xfrm>
+        </p:spPr>
+        <p:txBody>
+          <a:bodyPr/>
+          <a:lstStyle/>
+          <a:p>
+            <a:pPr lvl="0" indent="0" marL="0">
+              <a:buNone/>
+            </a:pPr>
+            <a:r>
+              <a:rPr/>
+              <a:t>Supplement · CMI rates</a:t>
+            </a:r>
+          </a:p>
+        </p:txBody>
+      </p:sp>
       <p:sp>
         <p:nvSpPr>
           <p:cNvPr id="8" name="Footer Placeholder 4">
@@ -22751,7 +23214,42 @@
           <a:chExt cx="0" cy="0"/>
         </a:xfrm>
       </p:grpSpPr>
-      <p:sp/>
+      <p:sp>
+        <p:nvSpPr>
+          <p:cNvPr id="914" name="Title 1">
+            <a:extLst>
+              <a:ext uri="{FF2B5EF4-FFF2-40B4-BE49-F238E27FC236}">
+                <a16:creationId xmlns:a16="http://schemas.microsoft.com/office/drawing/2014/main" id="{EF499182-B1CD-4399-99FD-7B1CA914FD59}"/>
+              </a:ext>
+            </a:extLst>
+          </p:cNvPr>
+          <p:cNvSpPr>
+            <a:spLocks noGrp="1"/>
+          </p:cNvSpPr>
+          <p:nvPr>
+            <p:ph hasCustomPrompt="1" type="title"/>
+          </p:nvPr>
+        </p:nvSpPr>
+        <p:spPr>
+          <a:xfrm>
+            <a:off x="1500000" y="3400000"/>
+            <a:ext cx="13256000" cy="2200000"/>
+          </a:xfrm>
+        </p:spPr>
+        <p:txBody>
+          <a:bodyPr/>
+          <a:lstStyle/>
+          <a:p>
+            <a:pPr lvl="0" indent="0" marL="0">
+              <a:buNone/>
+            </a:pPr>
+            <a:r>
+              <a:rPr/>
+              <a:t>Supplement · Close</a:t>
+            </a:r>
+          </a:p>
+        </p:txBody>
+      </p:sp>
       <p:sp>
         <p:nvSpPr>
           <p:cNvPr id="8" name="Footer Placeholder 4">
@@ -23166,7 +23664,42 @@
           <a:chExt cx="0" cy="0"/>
         </a:xfrm>
       </p:grpSpPr>
-      <p:sp/>
+      <p:sp>
+        <p:nvSpPr>
+          <p:cNvPr id="914" name="Title 1">
+            <a:extLst>
+              <a:ext uri="{FF2B5EF4-FFF2-40B4-BE49-F238E27FC236}">
+                <a16:creationId xmlns:a16="http://schemas.microsoft.com/office/drawing/2014/main" id="{EF499182-B1CD-4399-99FD-7B1CA914FD59}"/>
+              </a:ext>
+            </a:extLst>
+          </p:cNvPr>
+          <p:cNvSpPr>
+            <a:spLocks noGrp="1"/>
+          </p:cNvSpPr>
+          <p:nvPr>
+            <p:ph hasCustomPrompt="1" type="title"/>
+          </p:nvPr>
+        </p:nvSpPr>
+        <p:spPr>
+          <a:xfrm>
+            <a:off x="1500000" y="3400000"/>
+            <a:ext cx="13256000" cy="2200000"/>
+          </a:xfrm>
+        </p:spPr>
+        <p:txBody>
+          <a:bodyPr/>
+          <a:lstStyle/>
+          <a:p>
+            <a:pPr lvl="0" indent="0" marL="0">
+              <a:buNone/>
+            </a:pPr>
+            <a:r>
+              <a:rPr/>
+              <a:t>MAIN DECK</a:t>
+            </a:r>
+          </a:p>
+        </p:txBody>
+      </p:sp>
       <p:sp>
         <p:nvSpPr>
           <p:cNvPr id="8" name="Footer Placeholder 4">

</xml_diff>

<commit_message>
Fix pptx placeholder geometry: post-render script copies layout positions into slides
Co-Authored-By: Claude Fable 5 <noreply@anthropic.com>
</commit_message>
<xml_diff>
--- a/presentations/ifoa/hwle_ifoa_life_2026.pptx
+++ b/presentations/ifoa/hwle_ifoa_life_2026.pptx
@@ -11758,9 +11758,17 @@
             <p:ph hasCustomPrompt="1" idx="13" sz="quarter"/>
           </p:nvPr>
         </p:nvSpPr>
+        <p:spPr>
+          <a:xfrm>
+            <a:off x="1104904" y="2269323"/>
+            <a:ext cx="14020800" cy="5659894"/>
+          </a:xfrm>
+        </p:spPr>
         <p:spPr/>
         <p:txBody>
-          <a:bodyPr/>
+          <a:bodyPr wrap="square" rtlCol="0">
+            <a:normAutofit/>
+          </a:bodyPr>
           <a:lstStyle/>
           <a:p>
             <a:pPr lvl="0" indent="0" marL="0">
@@ -11995,9 +12003,17 @@
             <p:ph hasCustomPrompt="1" idx="13" sz="quarter"/>
           </p:nvPr>
         </p:nvSpPr>
+        <p:spPr>
+          <a:xfrm>
+            <a:off x="1104904" y="2269323"/>
+            <a:ext cx="14020800" cy="5659894"/>
+          </a:xfrm>
+        </p:spPr>
         <p:spPr/>
         <p:txBody>
-          <a:bodyPr/>
+          <a:bodyPr wrap="square" rtlCol="0">
+            <a:normAutofit/>
+          </a:bodyPr>
           <a:lstStyle/>
           <a:p>
             <a:pPr lvl="0" indent="0" marL="0">
@@ -12209,9 +12225,17 @@
             <p:ph hasCustomPrompt="1" idx="13" sz="quarter"/>
           </p:nvPr>
         </p:nvSpPr>
+        <p:spPr>
+          <a:xfrm>
+            <a:off x="1104904" y="2269323"/>
+            <a:ext cx="14020800" cy="5659894"/>
+          </a:xfrm>
+        </p:spPr>
         <p:spPr/>
         <p:txBody>
-          <a:bodyPr/>
+          <a:bodyPr wrap="square" rtlCol="0">
+            <a:normAutofit/>
+          </a:bodyPr>
           <a:lstStyle/>
           <a:p>
             <a:pPr lvl="0"/>
@@ -12574,9 +12598,17 @@
             <p:ph hasCustomPrompt="1" idx="13" sz="quarter"/>
           </p:nvPr>
         </p:nvSpPr>
+        <p:spPr>
+          <a:xfrm>
+            <a:off x="1104904" y="2269323"/>
+            <a:ext cx="14020800" cy="5659894"/>
+          </a:xfrm>
+        </p:spPr>
         <p:spPr/>
         <p:txBody>
-          <a:bodyPr/>
+          <a:bodyPr wrap="square" rtlCol="0">
+            <a:normAutofit/>
+          </a:bodyPr>
           <a:lstStyle/>
           <a:p>
             <a:pPr lvl="0"/>
@@ -13059,9 +13091,17 @@
             <p:ph hasCustomPrompt="1" idx="13" sz="quarter"/>
           </p:nvPr>
         </p:nvSpPr>
+        <p:spPr>
+          <a:xfrm>
+            <a:off x="1104904" y="2269323"/>
+            <a:ext cx="14020800" cy="5659894"/>
+          </a:xfrm>
+        </p:spPr>
         <p:spPr/>
         <p:txBody>
-          <a:bodyPr/>
+          <a:bodyPr wrap="square" rtlCol="0">
+            <a:normAutofit/>
+          </a:bodyPr>
           <a:lstStyle/>
           <a:p>
             <a:pPr lvl="0"/>
@@ -13303,9 +13343,17 @@
             <p:ph hasCustomPrompt="1" idx="13" sz="quarter"/>
           </p:nvPr>
         </p:nvSpPr>
+        <p:spPr>
+          <a:xfrm>
+            <a:off x="1104904" y="2269323"/>
+            <a:ext cx="6896104" cy="5459310"/>
+          </a:xfrm>
+        </p:spPr>
         <p:spPr/>
         <p:txBody>
-          <a:bodyPr/>
+          <a:bodyPr wrap="square" rtlCol="0">
+            <a:normAutofit/>
+          </a:bodyPr>
           <a:lstStyle/>
           <a:p>
             <a:pPr lvl="0" indent="0" marL="0">
@@ -13378,9 +13426,17 @@
             <p:ph hasCustomPrompt="1" idx="25" sz="quarter"/>
           </p:nvPr>
         </p:nvSpPr>
+        <p:spPr>
+          <a:xfrm>
+            <a:off x="8229600" y="2269322"/>
+            <a:ext cx="6896104" cy="5459309"/>
+          </a:xfrm>
+        </p:spPr>
         <p:spPr/>
         <p:txBody>
-          <a:bodyPr/>
+          <a:bodyPr wrap="square" rtlCol="0">
+            <a:normAutofit/>
+          </a:bodyPr>
           <a:lstStyle/>
           <a:p>
             <a:pPr lvl="0" indent="0" marL="0">
@@ -13555,9 +13611,17 @@
             <p:ph hasCustomPrompt="1" idx="13" sz="quarter"/>
           </p:nvPr>
         </p:nvSpPr>
+        <p:spPr>
+          <a:xfrm>
+            <a:off x="1104904" y="2269323"/>
+            <a:ext cx="14020800" cy="5659894"/>
+          </a:xfrm>
+        </p:spPr>
         <p:spPr/>
         <p:txBody>
-          <a:bodyPr/>
+          <a:bodyPr wrap="square" rtlCol="0">
+            <a:normAutofit/>
+          </a:bodyPr>
           <a:lstStyle/>
           <a:p>
             <a:pPr lvl="0" indent="0" marL="0">
@@ -13902,9 +13966,17 @@
             <p:ph hasCustomPrompt="1" idx="13" sz="quarter"/>
           </p:nvPr>
         </p:nvSpPr>
+        <p:spPr>
+          <a:xfrm>
+            <a:off x="1104904" y="2269323"/>
+            <a:ext cx="14020800" cy="5659894"/>
+          </a:xfrm>
+        </p:spPr>
         <p:spPr/>
         <p:txBody>
-          <a:bodyPr/>
+          <a:bodyPr wrap="square" rtlCol="0">
+            <a:normAutofit/>
+          </a:bodyPr>
           <a:lstStyle/>
           <a:p>
             <a:pPr lvl="0"/>
@@ -14344,9 +14416,17 @@
             <p:ph hasCustomPrompt="1" idx="25" sz="quarter"/>
           </p:nvPr>
         </p:nvSpPr>
+        <p:spPr>
+          <a:xfrm>
+            <a:off x="8229600" y="2269322"/>
+            <a:ext cx="6896104" cy="5459309"/>
+          </a:xfrm>
+        </p:spPr>
         <p:spPr/>
         <p:txBody>
-          <a:bodyPr/>
+          <a:bodyPr wrap="square" rtlCol="0">
+            <a:normAutofit/>
+          </a:bodyPr>
           <a:lstStyle/>
           <a:p>
             <a:pPr lvl="0"/>
@@ -14579,9 +14659,17 @@
             <p:ph hasCustomPrompt="1" idx="24" sz="quarter" type="body"/>
           </p:nvPr>
         </p:nvSpPr>
+        <p:spPr>
+          <a:xfrm>
+            <a:off x="1117601" y="1214783"/>
+            <a:ext cx="7835897" cy="653900"/>
+          </a:xfrm>
+        </p:spPr>
         <p:spPr/>
         <p:txBody>
-          <a:bodyPr/>
+          <a:bodyPr wrap="square" rtlCol="0">
+            <a:normAutofit/>
+          </a:bodyPr>
           <a:lstStyle/>
           <a:p>
             <a:pPr lvl="0" indent="0" marL="0">
@@ -14926,9 +15014,17 @@
             <p:ph hasCustomPrompt="1" idx="13" sz="quarter"/>
           </p:nvPr>
         </p:nvSpPr>
+        <p:spPr>
+          <a:xfrm>
+            <a:off x="1104904" y="2269323"/>
+            <a:ext cx="14020800" cy="5659894"/>
+          </a:xfrm>
+        </p:spPr>
         <p:spPr/>
         <p:txBody>
-          <a:bodyPr/>
+          <a:bodyPr wrap="square" rtlCol="0">
+            <a:normAutofit/>
+          </a:bodyPr>
           <a:lstStyle/>
           <a:p>
             <a:pPr lvl="0"/>
@@ -15825,9 +15921,17 @@
             <p:ph hasCustomPrompt="1" idx="13" sz="quarter"/>
           </p:nvPr>
         </p:nvSpPr>
+        <p:spPr>
+          <a:xfrm>
+            <a:off x="1104904" y="2269323"/>
+            <a:ext cx="14020800" cy="5659894"/>
+          </a:xfrm>
+        </p:spPr>
         <p:spPr/>
         <p:txBody>
-          <a:bodyPr/>
+          <a:bodyPr wrap="square" rtlCol="0">
+            <a:normAutofit/>
+          </a:bodyPr>
           <a:lstStyle/>
           <a:p>
             <a:pPr lvl="0" indent="0" marL="0">
@@ -16026,9 +16130,17 @@
             <p:ph hasCustomPrompt="1" idx="13" sz="quarter"/>
           </p:nvPr>
         </p:nvSpPr>
+        <p:spPr>
+          <a:xfrm>
+            <a:off x="1104904" y="2269323"/>
+            <a:ext cx="14020800" cy="5659894"/>
+          </a:xfrm>
+        </p:spPr>
         <p:spPr/>
         <p:txBody>
-          <a:bodyPr/>
+          <a:bodyPr wrap="square" rtlCol="0">
+            <a:normAutofit/>
+          </a:bodyPr>
           <a:lstStyle/>
           <a:p>
             <a:pPr lvl="0"/>
@@ -16258,9 +16370,17 @@
             <p:ph hasCustomPrompt="1" idx="13" sz="quarter"/>
           </p:nvPr>
         </p:nvSpPr>
+        <p:spPr>
+          <a:xfrm>
+            <a:off x="1104904" y="2269323"/>
+            <a:ext cx="14020800" cy="5659894"/>
+          </a:xfrm>
+        </p:spPr>
         <p:spPr/>
         <p:txBody>
-          <a:bodyPr/>
+          <a:bodyPr wrap="square" rtlCol="0">
+            <a:normAutofit/>
+          </a:bodyPr>
           <a:lstStyle/>
           <a:p>
             <a:pPr lvl="0"/>
@@ -16476,9 +16596,17 @@
             <p:ph hasCustomPrompt="1" idx="13" sz="quarter"/>
           </p:nvPr>
         </p:nvSpPr>
+        <p:spPr>
+          <a:xfrm>
+            <a:off x="1104904" y="2269323"/>
+            <a:ext cx="14020800" cy="5659894"/>
+          </a:xfrm>
+        </p:spPr>
         <p:spPr/>
         <p:txBody>
-          <a:bodyPr/>
+          <a:bodyPr wrap="square" rtlCol="0">
+            <a:normAutofit/>
+          </a:bodyPr>
           <a:lstStyle/>
           <a:p>
             <a:pPr lvl="0"/>
@@ -16702,9 +16830,17 @@
             <p:ph hasCustomPrompt="1" idx="13" sz="quarter"/>
           </p:nvPr>
         </p:nvSpPr>
+        <p:spPr>
+          <a:xfrm>
+            <a:off x="1104904" y="2269323"/>
+            <a:ext cx="14020800" cy="5659894"/>
+          </a:xfrm>
+        </p:spPr>
         <p:spPr/>
         <p:txBody>
-          <a:bodyPr/>
+          <a:bodyPr wrap="square" rtlCol="0">
+            <a:normAutofit/>
+          </a:bodyPr>
           <a:lstStyle/>
           <a:p>
             <a:pPr lvl="0"/>
@@ -17072,9 +17208,17 @@
             <p:ph hasCustomPrompt="1" idx="13" sz="quarter"/>
           </p:nvPr>
         </p:nvSpPr>
+        <p:spPr>
+          <a:xfrm>
+            <a:off x="1104904" y="2269323"/>
+            <a:ext cx="14020800" cy="5659894"/>
+          </a:xfrm>
+        </p:spPr>
         <p:spPr/>
         <p:txBody>
-          <a:bodyPr/>
+          <a:bodyPr wrap="square" rtlCol="0">
+            <a:normAutofit/>
+          </a:bodyPr>
           <a:lstStyle/>
           <a:p>
             <a:pPr lvl="0" indent="0" marL="0">
@@ -17283,9 +17427,17 @@
             <p:ph hasCustomPrompt="1" idx="13" sz="quarter"/>
           </p:nvPr>
         </p:nvSpPr>
+        <p:spPr>
+          <a:xfrm>
+            <a:off x="1104904" y="2269323"/>
+            <a:ext cx="14020800" cy="5659894"/>
+          </a:xfrm>
+        </p:spPr>
         <p:spPr/>
         <p:txBody>
-          <a:bodyPr/>
+          <a:bodyPr wrap="square" rtlCol="0">
+            <a:normAutofit/>
+          </a:bodyPr>
           <a:lstStyle/>
           <a:p>
             <a:pPr lvl="0"/>
@@ -17641,9 +17793,17 @@
             <p:ph hasCustomPrompt="1" idx="13" sz="quarter"/>
           </p:nvPr>
         </p:nvSpPr>
+        <p:spPr>
+          <a:xfrm>
+            <a:off x="1104904" y="2269323"/>
+            <a:ext cx="14020800" cy="5659894"/>
+          </a:xfrm>
+        </p:spPr>
         <p:spPr/>
         <p:txBody>
-          <a:bodyPr/>
+          <a:bodyPr wrap="square" rtlCol="0">
+            <a:normAutofit/>
+          </a:bodyPr>
           <a:lstStyle/>
           <a:p>
             <a:pPr lvl="0"/>
@@ -18012,9 +18172,17 @@
             <p:ph hasCustomPrompt="1" idx="13" sz="quarter"/>
           </p:nvPr>
         </p:nvSpPr>
+        <p:spPr>
+          <a:xfrm>
+            <a:off x="1104904" y="2269323"/>
+            <a:ext cx="14020800" cy="5659894"/>
+          </a:xfrm>
+        </p:spPr>
         <p:spPr/>
         <p:txBody>
-          <a:bodyPr/>
+          <a:bodyPr wrap="square" rtlCol="0">
+            <a:normAutofit/>
+          </a:bodyPr>
           <a:lstStyle/>
           <a:p>
             <a:pPr lvl="0"/>
@@ -19103,9 +19271,17 @@
             <p:ph hasCustomPrompt="1" idx="13" sz="quarter"/>
           </p:nvPr>
         </p:nvSpPr>
+        <p:spPr>
+          <a:xfrm>
+            <a:off x="1104904" y="2269323"/>
+            <a:ext cx="6896104" cy="5459310"/>
+          </a:xfrm>
+        </p:spPr>
         <p:spPr/>
         <p:txBody>
-          <a:bodyPr/>
+          <a:bodyPr wrap="square" rtlCol="0">
+            <a:normAutofit/>
+          </a:bodyPr>
           <a:lstStyle/>
           <a:p>
             <a:pPr lvl="0" indent="0" marL="0">
@@ -19169,9 +19345,17 @@
             <p:ph hasCustomPrompt="1" idx="25" sz="quarter"/>
           </p:nvPr>
         </p:nvSpPr>
+        <p:spPr>
+          <a:xfrm>
+            <a:off x="8229600" y="2269322"/>
+            <a:ext cx="6896104" cy="5459309"/>
+          </a:xfrm>
+        </p:spPr>
         <p:spPr/>
         <p:txBody>
-          <a:bodyPr/>
+          <a:bodyPr wrap="square" rtlCol="0">
+            <a:normAutofit/>
+          </a:bodyPr>
           <a:lstStyle/>
           <a:p>
             <a:pPr lvl="0" indent="0" marL="0">
@@ -19709,9 +19893,17 @@
             <p:ph hasCustomPrompt="1" idx="13" sz="quarter"/>
           </p:nvPr>
         </p:nvSpPr>
+        <p:spPr>
+          <a:xfrm>
+            <a:off x="1104904" y="2269323"/>
+            <a:ext cx="14020800" cy="5659894"/>
+          </a:xfrm>
+        </p:spPr>
         <p:spPr/>
         <p:txBody>
-          <a:bodyPr/>
+          <a:bodyPr wrap="square" rtlCol="0">
+            <a:normAutofit/>
+          </a:bodyPr>
           <a:lstStyle/>
           <a:p>
             <a:pPr lvl="0"/>
@@ -21385,9 +21577,17 @@
             <p:ph hasCustomPrompt="1" idx="13" sz="quarter"/>
           </p:nvPr>
         </p:nvSpPr>
+        <p:spPr>
+          <a:xfrm>
+            <a:off x="1104904" y="2269323"/>
+            <a:ext cx="14020800" cy="5659894"/>
+          </a:xfrm>
+        </p:spPr>
         <p:spPr/>
         <p:txBody>
-          <a:bodyPr/>
+          <a:bodyPr wrap="square" rtlCol="0">
+            <a:normAutofit/>
+          </a:bodyPr>
           <a:lstStyle/>
           <a:p>
             <a:pPr lvl="0" indent="0" marL="0">
@@ -21964,9 +22164,17 @@
             <p:ph hasCustomPrompt="1" idx="13" sz="quarter"/>
           </p:nvPr>
         </p:nvSpPr>
+        <p:spPr>
+          <a:xfrm>
+            <a:off x="1104904" y="2269323"/>
+            <a:ext cx="14020800" cy="5659894"/>
+          </a:xfrm>
+        </p:spPr>
         <p:spPr/>
         <p:txBody>
-          <a:bodyPr/>
+          <a:bodyPr wrap="square" rtlCol="0">
+            <a:normAutofit/>
+          </a:bodyPr>
           <a:lstStyle/>
           <a:p>
             <a:pPr lvl="0" indent="0" marL="0">
@@ -22673,9 +22881,17 @@
             <p:ph hasCustomPrompt="1" idx="13" sz="quarter"/>
           </p:nvPr>
         </p:nvSpPr>
+        <p:spPr>
+          <a:xfrm>
+            <a:off x="1104904" y="2269323"/>
+            <a:ext cx="14020800" cy="5659894"/>
+          </a:xfrm>
+        </p:spPr>
         <p:spPr/>
         <p:txBody>
-          <a:bodyPr/>
+          <a:bodyPr wrap="square" rtlCol="0">
+            <a:normAutofit/>
+          </a:bodyPr>
           <a:lstStyle/>
           <a:p>
             <a:pPr lvl="0" indent="0" marL="0">
@@ -22858,9 +23074,17 @@
             <p:ph hasCustomPrompt="1" idx="13" sz="quarter"/>
           </p:nvPr>
         </p:nvSpPr>
+        <p:spPr>
+          <a:xfrm>
+            <a:off x="1104904" y="2269323"/>
+            <a:ext cx="14020800" cy="5659894"/>
+          </a:xfrm>
+        </p:spPr>
         <p:spPr/>
         <p:txBody>
-          <a:bodyPr/>
+          <a:bodyPr wrap="square" rtlCol="0">
+            <a:normAutofit/>
+          </a:bodyPr>
           <a:lstStyle/>
           <a:p>
             <a:pPr lvl="0"/>
@@ -23420,9 +23644,17 @@
             <p:ph hasCustomPrompt="1" idx="13" sz="quarter"/>
           </p:nvPr>
         </p:nvSpPr>
+        <p:spPr>
+          <a:xfrm>
+            <a:off x="1104904" y="2269323"/>
+            <a:ext cx="14020800" cy="5659894"/>
+          </a:xfrm>
+        </p:spPr>
         <p:spPr/>
         <p:txBody>
-          <a:bodyPr/>
+          <a:bodyPr wrap="square" rtlCol="0">
+            <a:normAutofit/>
+          </a:bodyPr>
           <a:lstStyle/>
           <a:p>
             <a:pPr lvl="0"/>
@@ -23870,9 +24102,17 @@
             <p:ph hasCustomPrompt="1" idx="13" sz="quarter"/>
           </p:nvPr>
         </p:nvSpPr>
+        <p:spPr>
+          <a:xfrm>
+            <a:off x="1104904" y="2269323"/>
+            <a:ext cx="14020800" cy="5659894"/>
+          </a:xfrm>
+        </p:spPr>
         <p:spPr/>
         <p:txBody>
-          <a:bodyPr/>
+          <a:bodyPr wrap="square" rtlCol="0">
+            <a:normAutofit/>
+          </a:bodyPr>
           <a:lstStyle/>
           <a:p>
             <a:pPr lvl="0" indent="-609585" marL="609585">
@@ -24120,9 +24360,17 @@
             <p:ph hasCustomPrompt="1" idx="13" sz="quarter"/>
           </p:nvPr>
         </p:nvSpPr>
+        <p:spPr>
+          <a:xfrm>
+            <a:off x="1104904" y="2269323"/>
+            <a:ext cx="14020800" cy="5659894"/>
+          </a:xfrm>
+        </p:spPr>
         <p:spPr/>
         <p:txBody>
-          <a:bodyPr/>
+          <a:bodyPr wrap="square" rtlCol="0">
+            <a:normAutofit/>
+          </a:bodyPr>
           <a:lstStyle/>
           <a:p>
             <a:pPr lvl="0" indent="0" marL="0">
@@ -24341,9 +24589,17 @@
             <p:ph hasCustomPrompt="1" idx="13" sz="quarter"/>
           </p:nvPr>
         </p:nvSpPr>
+        <p:spPr>
+          <a:xfrm>
+            <a:off x="1104904" y="2269323"/>
+            <a:ext cx="14020800" cy="5659894"/>
+          </a:xfrm>
+        </p:spPr>
         <p:spPr/>
         <p:txBody>
-          <a:bodyPr/>
+          <a:bodyPr wrap="square" rtlCol="0">
+            <a:normAutofit/>
+          </a:bodyPr>
           <a:lstStyle/>
           <a:p>
             <a:pPr lvl="0"/>

</xml_diff>

<commit_message>
Rebuild IFoA reference pptx with a single slide master to stop PowerPoint repair prompt
Diagnosed by diffing PowerPoint's repaired save against the render: the
template has three slide masters and pandoc copied relationships to
slideMaster2/3, customXml, authors.xml, handoutMaster and changesInfo
that were absent from the output. build_reference.py now derives the
reference from the pristine template reproducibly (layout renames,
placeholder patches, master consolidation, dangling-part removal).
fix_pptx.py also renumbers duplicate shape ids pandoc emits.

Co-Authored-By: Claude Fable 5 <noreply@anthropic.com>
</commit_message>
<xml_diff>
--- a/presentations/ifoa/hwle_ifoa_life_2026.pptx
+++ b/presentations/ifoa/hwle_ifoa_life_2026.pptx
@@ -3,64 +3,62 @@
 <p:presentation xmlns:a="http://schemas.openxmlformats.org/drawingml/2006/main" xmlns:p="http://schemas.openxmlformats.org/presentationml/2006/main" xmlns:r="http://schemas.openxmlformats.org/officeDocument/2006/relationships">
   <p:sldMasterIdLst>
     <p:sldMasterId id="2147484060" r:id="rId4"/>
-    <p:sldMasterId id="2147484090" r:id="rId5"/>
-    <p:sldMasterId id="2147483897" r:id="rId6"/>
   </p:sldMasterIdLst>
   <p:notesMasterIdLst>
-    <p:notesMasterId r:id="rId58"/>
+    <p:notesMasterId r:id="rId56"/>
   </p:notesMasterIdLst>
   <p:sldIdLst>
-    <p:sldId id="256" r:id="rId7"/>
-    <p:sldId id="257" r:id="rId8"/>
-    <p:sldId id="258" r:id="rId9"/>
-    <p:sldId id="259" r:id="rId10"/>
-    <p:sldId id="260" r:id="rId11"/>
-    <p:sldId id="261" r:id="rId12"/>
-    <p:sldId id="262" r:id="rId13"/>
-    <p:sldId id="263" r:id="rId14"/>
-    <p:sldId id="264" r:id="rId15"/>
-    <p:sldId id="265" r:id="rId16"/>
-    <p:sldId id="266" r:id="rId17"/>
-    <p:sldId id="267" r:id="rId18"/>
-    <p:sldId id="268" r:id="rId19"/>
-    <p:sldId id="269" r:id="rId20"/>
-    <p:sldId id="270" r:id="rId21"/>
-    <p:sldId id="271" r:id="rId22"/>
-    <p:sldId id="272" r:id="rId23"/>
-    <p:sldId id="273" r:id="rId24"/>
-    <p:sldId id="274" r:id="rId25"/>
-    <p:sldId id="275" r:id="rId26"/>
-    <p:sldId id="276" r:id="rId27"/>
-    <p:sldId id="277" r:id="rId28"/>
-    <p:sldId id="278" r:id="rId29"/>
-    <p:sldId id="279" r:id="rId30"/>
-    <p:sldId id="280" r:id="rId31"/>
-    <p:sldId id="281" r:id="rId32"/>
-    <p:sldId id="282" r:id="rId33"/>
-    <p:sldId id="283" r:id="rId34"/>
-    <p:sldId id="284" r:id="rId35"/>
-    <p:sldId id="285" r:id="rId36"/>
-    <p:sldId id="286" r:id="rId37"/>
-    <p:sldId id="287" r:id="rId38"/>
-    <p:sldId id="288" r:id="rId39"/>
-    <p:sldId id="289" r:id="rId40"/>
-    <p:sldId id="290" r:id="rId41"/>
-    <p:sldId id="291" r:id="rId42"/>
-    <p:sldId id="292" r:id="rId43"/>
-    <p:sldId id="293" r:id="rId44"/>
-    <p:sldId id="294" r:id="rId45"/>
-    <p:sldId id="295" r:id="rId46"/>
-    <p:sldId id="296" r:id="rId47"/>
-    <p:sldId id="297" r:id="rId48"/>
-    <p:sldId id="298" r:id="rId49"/>
-    <p:sldId id="299" r:id="rId50"/>
-    <p:sldId id="300" r:id="rId51"/>
-    <p:sldId id="301" r:id="rId52"/>
-    <p:sldId id="302" r:id="rId53"/>
-    <p:sldId id="303" r:id="rId54"/>
-    <p:sldId id="304" r:id="rId55"/>
-    <p:sldId id="305" r:id="rId56"/>
-    <p:sldId id="306" r:id="rId57"/>
+    <p:sldId id="256" r:id="rId5"/>
+    <p:sldId id="257" r:id="rId6"/>
+    <p:sldId id="258" r:id="rId7"/>
+    <p:sldId id="259" r:id="rId8"/>
+    <p:sldId id="260" r:id="rId9"/>
+    <p:sldId id="261" r:id="rId10"/>
+    <p:sldId id="262" r:id="rId11"/>
+    <p:sldId id="263" r:id="rId12"/>
+    <p:sldId id="264" r:id="rId13"/>
+    <p:sldId id="265" r:id="rId14"/>
+    <p:sldId id="266" r:id="rId15"/>
+    <p:sldId id="267" r:id="rId16"/>
+    <p:sldId id="268" r:id="rId17"/>
+    <p:sldId id="269" r:id="rId18"/>
+    <p:sldId id="270" r:id="rId19"/>
+    <p:sldId id="271" r:id="rId20"/>
+    <p:sldId id="272" r:id="rId21"/>
+    <p:sldId id="273" r:id="rId22"/>
+    <p:sldId id="274" r:id="rId23"/>
+    <p:sldId id="275" r:id="rId24"/>
+    <p:sldId id="276" r:id="rId25"/>
+    <p:sldId id="277" r:id="rId26"/>
+    <p:sldId id="278" r:id="rId27"/>
+    <p:sldId id="279" r:id="rId28"/>
+    <p:sldId id="280" r:id="rId29"/>
+    <p:sldId id="281" r:id="rId30"/>
+    <p:sldId id="282" r:id="rId31"/>
+    <p:sldId id="283" r:id="rId32"/>
+    <p:sldId id="284" r:id="rId33"/>
+    <p:sldId id="285" r:id="rId34"/>
+    <p:sldId id="286" r:id="rId35"/>
+    <p:sldId id="287" r:id="rId36"/>
+    <p:sldId id="288" r:id="rId37"/>
+    <p:sldId id="289" r:id="rId38"/>
+    <p:sldId id="290" r:id="rId39"/>
+    <p:sldId id="291" r:id="rId40"/>
+    <p:sldId id="292" r:id="rId41"/>
+    <p:sldId id="293" r:id="rId42"/>
+    <p:sldId id="294" r:id="rId43"/>
+    <p:sldId id="295" r:id="rId44"/>
+    <p:sldId id="296" r:id="rId45"/>
+    <p:sldId id="297" r:id="rId46"/>
+    <p:sldId id="298" r:id="rId47"/>
+    <p:sldId id="299" r:id="rId48"/>
+    <p:sldId id="300" r:id="rId49"/>
+    <p:sldId id="301" r:id="rId50"/>
+    <p:sldId id="302" r:id="rId51"/>
+    <p:sldId id="303" r:id="rId52"/>
+    <p:sldId id="304" r:id="rId53"/>
+    <p:sldId id="305" r:id="rId54"/>
+    <p:sldId id="306" r:id="rId55"/>
   </p:sldIdLst>
   <p:sldSz cx="16256000" cy="9144000"/>
   <p:notesSz cx="16256000" cy="9144000"/>
@@ -1067,7 +1065,7 @@
           <p:cNvPr id="70" name="Subtitle 2">
             <a:extLst>
               <a:ext uri="{FF2B5EF4-FFF2-40B4-BE49-F238E27FC236}">
-                <a16:creationId xmlns:a16="http://schemas.microsoft.com/office/drawing/2014/main" id="{6AA7276D-7192-0B34-473D-EA39E90AE911}"/>
+                <a16:creationId xmlns:a16="http://schemas.microsoft.com/office/drawing/2014/main" id="{6AA7276D-7192-0B34-473D-EA39E90AE910}"/>
               </a:ext>
             </a:extLst>
           </p:cNvPr>
@@ -7665,7 +7663,7 @@
       </p:cxnSp>
       <p:sp>
         <p:nvSpPr>
-          <p:cNvPr id="914" name="Title 1">
+          <p:cNvPr id="97" name="Title 1">
             <a:extLst>
               <a:ext uri="{FF2B5EF4-FFF2-40B4-BE49-F238E27FC236}">
                 <a16:creationId xmlns:a16="http://schemas.microsoft.com/office/drawing/2014/main" id="{EF499182-B1CD-4399-99FD-7B1CA914FD59}"/>
@@ -10692,10 +10690,10 @@
       </p:grpSpPr>
       <p:sp>
         <p:nvSpPr>
-          <p:cNvPr id="5" name="Title Placeholder 1">
-            <a:extLst>
-              <a:ext uri="{FF2B5EF4-FFF2-40B4-BE49-F238E27FC236}">
-                <a16:creationId xmlns:a16="http://schemas.microsoft.com/office/drawing/2014/main" id="{FF25C570-C0B9-76B3-4BFD-E6B3A0571624}"/>
+          <p:cNvPr id="2" name="Title Placeholder 1">
+            <a:extLst>
+              <a:ext uri="{FF2B5EF4-FFF2-40B4-BE49-F238E27FC236}">
+                <a16:creationId xmlns:a16="http://schemas.microsoft.com/office/drawing/2014/main" id="{C3F9E5E3-50B6-4FBB-92A3-9FF023DDE2C5}"/>
               </a:ext>
             </a:extLst>
           </p:cNvPr>
@@ -10730,10 +10728,10 @@
       </p:sp>
       <p:sp>
         <p:nvSpPr>
-          <p:cNvPr id="6" name="Text Placeholder 2">
-            <a:extLst>
-              <a:ext uri="{FF2B5EF4-FFF2-40B4-BE49-F238E27FC236}">
-                <a16:creationId xmlns:a16="http://schemas.microsoft.com/office/drawing/2014/main" id="{A630D8FD-A6F6-6EE4-2434-A38016314418}"/>
+          <p:cNvPr id="3" name="Text Placeholder 2">
+            <a:extLst>
+              <a:ext uri="{FF2B5EF4-FFF2-40B4-BE49-F238E27FC236}">
+                <a16:creationId xmlns:a16="http://schemas.microsoft.com/office/drawing/2014/main" id="{CD748E6F-0121-4691-8E7F-4F7004A7CAA4}"/>
               </a:ext>
             </a:extLst>
           </p:cNvPr>
@@ -10795,47 +10793,12 @@
           </a:p>
         </p:txBody>
       </p:sp>
-      <p:pic>
-        <p:nvPicPr>
-          <p:cNvPr id="7" name="Picture 6">
-            <a:extLst>
-              <a:ext uri="{FF2B5EF4-FFF2-40B4-BE49-F238E27FC236}">
-                <a16:creationId xmlns:a16="http://schemas.microsoft.com/office/drawing/2014/main" id="{BDD3F4E8-5CDA-8955-4BFE-A2FCDD5BA013}"/>
-              </a:ext>
-            </a:extLst>
-          </p:cNvPr>
-          <p:cNvPicPr>
-            <a:picLocks noChangeAspect="1"/>
-          </p:cNvPicPr>
-          <p:nvPr userDrawn="1"/>
-        </p:nvPicPr>
-        <p:blipFill>
-          <a:blip cstate="email" r:embed="rId3">
-            <a:extLst>
-              <a:ext uri="{28A0092B-C50C-407E-A947-70E740481C1C}">
-                <a14:useLocalDpi xmlns:a14="http://schemas.microsoft.com/office/drawing/2010/main" val="0"/>
-              </a:ext>
-            </a:extLst>
-          </a:blip>
-          <a:srcRect/>
-          <a:stretch/>
-        </p:blipFill>
-        <p:spPr>
-          <a:xfrm>
-            <a:off x="12850415" y="8348635"/>
-            <a:ext cx="1366353" cy="554629"/>
-          </a:xfrm>
-          <a:prstGeom prst="rect">
-            <a:avLst/>
-          </a:prstGeom>
-        </p:spPr>
-      </p:pic>
-      <p:sp>
-        <p:nvSpPr>
-          <p:cNvPr id="8" name="Footer Placeholder 4">
-            <a:extLst>
-              <a:ext uri="{FF2B5EF4-FFF2-40B4-BE49-F238E27FC236}">
-                <a16:creationId xmlns:a16="http://schemas.microsoft.com/office/drawing/2014/main" id="{ACA03778-E4AF-D519-D257-3D5B728D22F7}"/>
+      <p:sp>
+        <p:nvSpPr>
+          <p:cNvPr id="22" name="Footer Placeholder 4">
+            <a:extLst>
+              <a:ext uri="{FF2B5EF4-FFF2-40B4-BE49-F238E27FC236}">
+                <a16:creationId xmlns:a16="http://schemas.microsoft.com/office/drawing/2014/main" id="{15B6EA79-ADD6-536F-9385-DD3D12B23CD5}"/>
               </a:ext>
             </a:extLst>
           </p:cNvPr>
@@ -10877,10 +10840,10 @@
       </p:sp>
       <p:sp>
         <p:nvSpPr>
-          <p:cNvPr id="9" name="Slide Number Placeholder 5">
-            <a:extLst>
-              <a:ext uri="{FF2B5EF4-FFF2-40B4-BE49-F238E27FC236}">
-                <a16:creationId xmlns:a16="http://schemas.microsoft.com/office/drawing/2014/main" id="{A1516921-5FEC-FB3B-75CE-FB6663376CD0}"/>
+          <p:cNvPr id="23" name="Slide Number Placeholder 5">
+            <a:extLst>
+              <a:ext uri="{FF2B5EF4-FFF2-40B4-BE49-F238E27FC236}">
+                <a16:creationId xmlns:a16="http://schemas.microsoft.com/office/drawing/2014/main" id="{E2592FD6-5F90-36CF-89E1-38DFB0DCDE60}"/>
               </a:ext>
             </a:extLst>
           </p:cNvPr>
@@ -10928,10 +10891,10 @@
       </p:sp>
       <p:cxnSp>
         <p:nvCxnSpPr>
-          <p:cNvPr id="10" name="Straight Connector 9">
-            <a:extLst>
-              <a:ext uri="{FF2B5EF4-FFF2-40B4-BE49-F238E27FC236}">
-                <a16:creationId xmlns:a16="http://schemas.microsoft.com/office/drawing/2014/main" id="{5B708CF7-AFA2-B03F-3762-97D636B572D0}"/>
+          <p:cNvPr id="24" name="Straight Connector 23">
+            <a:extLst>
+              <a:ext uri="{FF2B5EF4-FFF2-40B4-BE49-F238E27FC236}">
+                <a16:creationId xmlns:a16="http://schemas.microsoft.com/office/drawing/2014/main" id="{CB2459A5-41A4-9F91-CD93-561B1A34EFD3}"/>
               </a:ext>
             </a:extLst>
           </p:cNvPr>
@@ -10971,10 +10934,10 @@
       </p:cxnSp>
       <p:cxnSp>
         <p:nvCxnSpPr>
-          <p:cNvPr id="11" name="Straight Connector 10">
-            <a:extLst>
-              <a:ext uri="{FF2B5EF4-FFF2-40B4-BE49-F238E27FC236}">
-                <a16:creationId xmlns:a16="http://schemas.microsoft.com/office/drawing/2014/main" id="{6F886170-12CD-9DF7-29C3-124E4C5EF48A}"/>
+          <p:cNvPr id="25" name="Straight Connector 24">
+            <a:extLst>
+              <a:ext uri="{FF2B5EF4-FFF2-40B4-BE49-F238E27FC236}">
+                <a16:creationId xmlns:a16="http://schemas.microsoft.com/office/drawing/2014/main" id="{193BB4BF-B293-D332-15CC-111A2FEAA3DA}"/>
               </a:ext>
             </a:extLst>
           </p:cNvPr>
@@ -11012,16 +10975,69 @@
           </a:fontRef>
         </p:style>
       </p:cxnSp>
+      <p:pic>
+        <p:nvPicPr>
+          <p:cNvPr id="5" name="Picture 4">
+            <a:extLst>
+              <a:ext uri="{FF2B5EF4-FFF2-40B4-BE49-F238E27FC236}">
+                <a16:creationId xmlns:a16="http://schemas.microsoft.com/office/drawing/2014/main" id="{C59BA104-4A55-2960-85E0-106CAE1FF314}"/>
+              </a:ext>
+            </a:extLst>
+          </p:cNvPr>
+          <p:cNvPicPr>
+            <a:picLocks noChangeAspect="1"/>
+          </p:cNvPicPr>
+          <p:nvPr userDrawn="1"/>
+        </p:nvPicPr>
+        <p:blipFill>
+          <a:blip cstate="email" r:embed="rId16">
+            <a:extLst>
+              <a:ext uri="{28A0092B-C50C-407E-A947-70E740481C1C}">
+                <a14:useLocalDpi xmlns:a14="http://schemas.microsoft.com/office/drawing/2010/main" val="0"/>
+              </a:ext>
+            </a:extLst>
+          </a:blip>
+          <a:srcRect/>
+          <a:stretch/>
+        </p:blipFill>
+        <p:spPr>
+          <a:xfrm>
+            <a:off x="12850416" y="8348635"/>
+            <a:ext cx="1366351" cy="554629"/>
+          </a:xfrm>
+          <a:prstGeom prst="rect">
+            <a:avLst/>
+          </a:prstGeom>
+        </p:spPr>
+      </p:pic>
     </p:spTree>
     <p:extLst>
       <p:ext uri="{BB962C8B-B14F-4D97-AF65-F5344CB8AC3E}">
-        <p14:creationId xmlns:p14="http://schemas.microsoft.com/office/powerpoint/2010/main" val="429686094"/>
+        <p14:creationId xmlns:p14="http://schemas.microsoft.com/office/powerpoint/2010/main" val="2805869975"/>
       </p:ext>
     </p:extLst>
   </p:cSld>
   <p:clrMap accent1="accent1" accent2="accent2" accent3="accent3" accent4="accent4" accent5="accent5" accent6="accent6" bg1="lt1" bg2="lt2" folHlink="folHlink" hlink="hlink" tx1="dk1" tx2="dk2"/>
   <p:sldLayoutIdLst>
-    <p:sldLayoutId id="2147483989" r:id="rId1"/>
+    <p:sldLayoutId id="2147484091" r:id="rId1"/>
+    <p:sldLayoutId id="2147484092" r:id="rId2"/>
+    <p:sldLayoutId id="2147484093" r:id="rId3"/>
+    <p:sldLayoutId id="2147484094" r:id="rId4"/>
+    <p:sldLayoutId id="2147484095" r:id="rId5"/>
+    <p:sldLayoutId id="2147484096" r:id="rId6"/>
+    <p:sldLayoutId id="2147484097" r:id="rId7"/>
+    <p:sldLayoutId id="2147484098" r:id="rId8"/>
+    <p:sldLayoutId id="2147484099" r:id="rId9"/>
+    <p:sldLayoutId id="2147484100" r:id="rId10"/>
+    <p:sldLayoutId id="2147484101" r:id="rId11"/>
+    <p:sldLayoutId id="2147484102" r:id="rId12"/>
+    <p:sldLayoutId id="2147484103" r:id="rId13"/>
+    <p:sldLayoutId id="2147484104" r:id="rId14"/>
+    <p:sldLayoutId id="2147484105" r:id="rId17"/>
+    <p:sldLayoutId id="2147484106" r:id="rId18"/>
+    <p:sldLayoutId id="2147484107" r:id="rId19"/>
+    <p:sldLayoutId id="2147484108" r:id="rId20"/>
+    <p:sldLayoutId id="2147484109" r:id="rId21"/>
   </p:sldLayoutIdLst>
   <p:hf dt="0" hdr="0"/>
   <p:txStyles>
@@ -11061,7 +11077,7 @@
           <a:solidFill>
             <a:schemeClr val="tx1"/>
           </a:solidFill>
-          <a:latin charset="77" pitchFamily="2" typeface="Arial Light"/>
+          <a:latin charset="0" panose="020B0604020202020204" pitchFamily="34" typeface="Arial"/>
           <a:ea typeface="+mn-ea"/>
           <a:cs charset="0" panose="020B0604020202020204" pitchFamily="34" typeface="Arial"/>
         </a:defRPr>
@@ -11082,7 +11098,7 @@
           <a:solidFill>
             <a:schemeClr val="tx1"/>
           </a:solidFill>
-          <a:latin charset="77" pitchFamily="2" typeface="Arial Light"/>
+          <a:latin charset="0" panose="020B0604020202020204" pitchFamily="34" typeface="Arial"/>
           <a:ea typeface="+mn-ea"/>
           <a:cs charset="0" panose="020B0604020202020204" pitchFamily="34" typeface="Arial"/>
         </a:defRPr>
@@ -11103,7 +11119,7 @@
           <a:solidFill>
             <a:schemeClr val="tx1"/>
           </a:solidFill>
-          <a:latin charset="77" pitchFamily="2" typeface="Arial Light"/>
+          <a:latin charset="0" panose="020B0604020202020204" pitchFamily="34" typeface="Arial"/>
           <a:ea typeface="+mn-ea"/>
           <a:cs charset="0" panose="020B0604020202020204" pitchFamily="34" typeface="Arial"/>
         </a:defRPr>
@@ -11124,7 +11140,7 @@
           <a:solidFill>
             <a:schemeClr val="tx1"/>
           </a:solidFill>
-          <a:latin charset="77" pitchFamily="2" typeface="Arial Light"/>
+          <a:latin charset="0" panose="020B0604020202020204" pitchFamily="34" typeface="Arial"/>
           <a:ea typeface="+mn-ea"/>
           <a:cs charset="0" panose="020B0604020202020204" pitchFamily="34" typeface="Arial"/>
         </a:defRPr>
@@ -11145,7 +11161,7 @@
           <a:solidFill>
             <a:schemeClr val="tx1"/>
           </a:solidFill>
-          <a:latin charset="77" pitchFamily="2" typeface="Arial Light"/>
+          <a:latin charset="0" panose="020B0604020202020204" pitchFamily="34" typeface="Arial"/>
           <a:ea typeface="+mn-ea"/>
           <a:cs charset="0" panose="020B0604020202020204" pitchFamily="34" typeface="Arial"/>
         </a:defRPr>
@@ -11383,7 +11399,7 @@
           <p:cNvPr id="70" name="Subtitle 2">
             <a:extLst>
               <a:ext uri="{FF2B5EF4-FFF2-40B4-BE49-F238E27FC236}">
-                <a16:creationId xmlns:a16="http://schemas.microsoft.com/office/drawing/2014/main" id="{6AA7276D-7192-0B34-473D-EA39E90AE911}"/>
+                <a16:creationId xmlns:a16="http://schemas.microsoft.com/office/drawing/2014/main" id="{6AA7276D-7192-0B34-473D-EA39E90AE910}"/>
               </a:ext>
             </a:extLst>
           </p:cNvPr>
@@ -11554,7 +11570,7 @@
       </p:grpSpPr>
       <p:sp>
         <p:nvSpPr>
-          <p:cNvPr id="914" name="Title 1">
+          <p:cNvPr id="97" name="Title 1">
             <a:extLst>
               <a:ext uri="{FF2B5EF4-FFF2-40B4-BE49-F238E27FC236}">
                 <a16:creationId xmlns:a16="http://schemas.microsoft.com/office/drawing/2014/main" id="{EF499182-B1CD-4399-99FD-7B1CA914FD59}"/>
@@ -12394,7 +12410,7 @@
       </p:grpSpPr>
       <p:sp>
         <p:nvSpPr>
-          <p:cNvPr id="914" name="Title 1">
+          <p:cNvPr id="97" name="Title 1">
             <a:extLst>
               <a:ext uri="{FF2B5EF4-FFF2-40B4-BE49-F238E27FC236}">
                 <a16:creationId xmlns:a16="http://schemas.microsoft.com/office/drawing/2014/main" id="{EF499182-B1CD-4399-99FD-7B1CA914FD59}"/>
@@ -12829,7 +12845,7 @@
       </p:pic>
       <p:sp>
         <p:nvSpPr>
-          <p:cNvPr id="1" name="TextBox 3"/>
+          <p:cNvPr id="9" name="TextBox 3"/>
           <p:cNvSpPr txBox="1"/>
           <p:nvPr>
             <p:ph idx="1"/>
@@ -12891,7 +12907,7 @@
       </p:pic>
       <p:sp>
         <p:nvSpPr>
-          <p:cNvPr id="1" name="TextBox 3"/>
+          <p:cNvPr id="10" name="TextBox 3"/>
           <p:cNvSpPr txBox="1"/>
           <p:nvPr>
             <p:ph idx="1"/>
@@ -13762,7 +13778,7 @@
       </p:grpSpPr>
       <p:sp>
         <p:nvSpPr>
-          <p:cNvPr id="914" name="Title 1">
+          <p:cNvPr id="97" name="Title 1">
             <a:extLst>
               <a:ext uri="{FF2B5EF4-FFF2-40B4-BE49-F238E27FC236}">
                 <a16:creationId xmlns:a16="http://schemas.microsoft.com/office/drawing/2014/main" id="{EF499182-B1CD-4399-99FD-7B1CA914FD59}"/>
@@ -14150,7 +14166,7 @@
       </p:grpSpPr>
       <p:sp>
         <p:nvSpPr>
-          <p:cNvPr id="914" name="Title 1">
+          <p:cNvPr id="97" name="Title 1">
             <a:extLst>
               <a:ext uri="{FF2B5EF4-FFF2-40B4-BE49-F238E27FC236}">
                 <a16:creationId xmlns:a16="http://schemas.microsoft.com/office/drawing/2014/main" id="{EF499182-B1CD-4399-99FD-7B1CA914FD59}"/>
@@ -14370,7 +14386,7 @@
       </p:pic>
       <p:sp>
         <p:nvSpPr>
-          <p:cNvPr id="1" name="TextBox 3"/>
+          <p:cNvPr id="15" name="TextBox 3"/>
           <p:cNvSpPr txBox="1"/>
           <p:nvPr>
             <p:ph idx="1"/>
@@ -15789,7 +15805,7 @@
       </p:graphicFrame>
       <p:sp>
         <p:nvSpPr>
-          <p:cNvPr id="6" name="Footer Placeholder 4">
+          <p:cNvPr id="15" name="Footer Placeholder 4">
             <a:extLst>
               <a:ext uri="{FF2B5EF4-FFF2-40B4-BE49-F238E27FC236}">
                 <a16:creationId xmlns:a16="http://schemas.microsoft.com/office/drawing/2014/main" id="{8F9D7237-5CD7-6037-7D60-81DA36BE7AA4}"/>
@@ -17589,7 +17605,7 @@
       </p:grpSpPr>
       <p:sp>
         <p:nvSpPr>
-          <p:cNvPr id="914" name="Title 1">
+          <p:cNvPr id="97" name="Title 1">
             <a:extLst>
               <a:ext uri="{FF2B5EF4-FFF2-40B4-BE49-F238E27FC236}">
                 <a16:creationId xmlns:a16="http://schemas.microsoft.com/office/drawing/2014/main" id="{EF499182-B1CD-4399-99FD-7B1CA914FD59}"/>
@@ -17968,7 +17984,7 @@
       </p:grpSpPr>
       <p:sp>
         <p:nvSpPr>
-          <p:cNvPr id="914" name="Title 1">
+          <p:cNvPr id="97" name="Title 1">
             <a:extLst>
               <a:ext uri="{FF2B5EF4-FFF2-40B4-BE49-F238E27FC236}">
                 <a16:creationId xmlns:a16="http://schemas.microsoft.com/office/drawing/2014/main" id="{EF499182-B1CD-4399-99FD-7B1CA914FD59}"/>
@@ -18949,7 +18965,7 @@
       </p:graphicFrame>
       <p:sp>
         <p:nvSpPr>
-          <p:cNvPr id="6" name="Footer Placeholder 4">
+          <p:cNvPr id="15" name="Footer Placeholder 4">
             <a:extLst>
               <a:ext uri="{FF2B5EF4-FFF2-40B4-BE49-F238E27FC236}">
                 <a16:creationId xmlns:a16="http://schemas.microsoft.com/office/drawing/2014/main" id="{8F9D7237-5CD7-6037-7D60-81DA36BE7AA4}"/>
@@ -19067,7 +19083,7 @@
       </p:grpSpPr>
       <p:sp>
         <p:nvSpPr>
-          <p:cNvPr id="914" name="Title 1">
+          <p:cNvPr id="97" name="Title 1">
             <a:extLst>
               <a:ext uri="{FF2B5EF4-FFF2-40B4-BE49-F238E27FC236}">
                 <a16:creationId xmlns:a16="http://schemas.microsoft.com/office/drawing/2014/main" id="{EF499182-B1CD-4399-99FD-7B1CA914FD59}"/>
@@ -19725,7 +19741,7 @@
       </p:graphicFrame>
       <p:sp>
         <p:nvSpPr>
-          <p:cNvPr id="6" name="Footer Placeholder 4">
+          <p:cNvPr id="15" name="Footer Placeholder 4">
             <a:extLst>
               <a:ext uri="{FF2B5EF4-FFF2-40B4-BE49-F238E27FC236}">
                 <a16:creationId xmlns:a16="http://schemas.microsoft.com/office/drawing/2014/main" id="{8F9D7237-5CD7-6037-7D60-81DA36BE7AA4}"/>
@@ -20197,7 +20213,7 @@
       </p:grpSpPr>
       <p:sp>
         <p:nvSpPr>
-          <p:cNvPr id="914" name="Title 1">
+          <p:cNvPr id="97" name="Title 1">
             <a:extLst>
               <a:ext uri="{FF2B5EF4-FFF2-40B4-BE49-F238E27FC236}">
                 <a16:creationId xmlns:a16="http://schemas.microsoft.com/office/drawing/2014/main" id="{EF499182-B1CD-4399-99FD-7B1CA914FD59}"/>
@@ -20417,7 +20433,7 @@
       </p:pic>
       <p:sp>
         <p:nvSpPr>
-          <p:cNvPr id="1" name="TextBox 3"/>
+          <p:cNvPr id="15" name="TextBox 3"/>
           <p:cNvSpPr txBox="1"/>
           <p:nvPr>
             <p:ph idx="1"/>
@@ -20793,7 +20809,7 @@
       </p:graphicFrame>
       <p:sp>
         <p:nvSpPr>
-          <p:cNvPr id="6" name="Footer Placeholder 4">
+          <p:cNvPr id="15" name="Footer Placeholder 4">
             <a:extLst>
               <a:ext uri="{FF2B5EF4-FFF2-40B4-BE49-F238E27FC236}">
                 <a16:creationId xmlns:a16="http://schemas.microsoft.com/office/drawing/2014/main" id="{8F9D7237-5CD7-6037-7D60-81DA36BE7AA4}"/>
@@ -21445,7 +21461,7 @@
       </p:graphicFrame>
       <p:sp>
         <p:nvSpPr>
-          <p:cNvPr id="6" name="Footer Placeholder 4">
+          <p:cNvPr id="15" name="Footer Placeholder 4">
             <a:extLst>
               <a:ext uri="{FF2B5EF4-FFF2-40B4-BE49-F238E27FC236}">
                 <a16:creationId xmlns:a16="http://schemas.microsoft.com/office/drawing/2014/main" id="{8F9D7237-5CD7-6037-7D60-81DA36BE7AA4}"/>
@@ -22032,7 +22048,7 @@
       </p:graphicFrame>
       <p:sp>
         <p:nvSpPr>
-          <p:cNvPr id="6" name="Footer Placeholder 4">
+          <p:cNvPr id="15" name="Footer Placeholder 4">
             <a:extLst>
               <a:ext uri="{FF2B5EF4-FFF2-40B4-BE49-F238E27FC236}">
                 <a16:creationId xmlns:a16="http://schemas.microsoft.com/office/drawing/2014/main" id="{8F9D7237-5CD7-6037-7D60-81DA36BE7AA4}"/>
@@ -22749,7 +22765,7 @@
       </p:graphicFrame>
       <p:sp>
         <p:nvSpPr>
-          <p:cNvPr id="6" name="Footer Placeholder 4">
+          <p:cNvPr id="15" name="Footer Placeholder 4">
             <a:extLst>
               <a:ext uri="{FF2B5EF4-FFF2-40B4-BE49-F238E27FC236}">
                 <a16:creationId xmlns:a16="http://schemas.microsoft.com/office/drawing/2014/main" id="{8F9D7237-5CD7-6037-7D60-81DA36BE7AA4}"/>
@@ -23440,7 +23456,7 @@
       </p:grpSpPr>
       <p:sp>
         <p:nvSpPr>
-          <p:cNvPr id="914" name="Title 1">
+          <p:cNvPr id="97" name="Title 1">
             <a:extLst>
               <a:ext uri="{FF2B5EF4-FFF2-40B4-BE49-F238E27FC236}">
                 <a16:creationId xmlns:a16="http://schemas.microsoft.com/office/drawing/2014/main" id="{EF499182-B1CD-4399-99FD-7B1CA914FD59}"/>
@@ -23898,7 +23914,7 @@
       </p:grpSpPr>
       <p:sp>
         <p:nvSpPr>
-          <p:cNvPr id="914" name="Title 1">
+          <p:cNvPr id="97" name="Title 1">
             <a:extLst>
               <a:ext uri="{FF2B5EF4-FFF2-40B4-BE49-F238E27FC236}">
                 <a16:creationId xmlns:a16="http://schemas.microsoft.com/office/drawing/2014/main" id="{EF499182-B1CD-4399-99FD-7B1CA914FD59}"/>
@@ -25025,267 +25041,6 @@
       </a:hlink>
       <a:folHlink>
         <a:srgbClr val="829AAC"/>
-      </a:folHlink>
-    </a:clrScheme>
-    <a:fontScheme name="Arial">
-      <a:majorFont>
-        <a:latin typeface="Arial" panose="020B0604020202020204"/>
-        <a:ea typeface=""/>
-        <a:cs typeface=""/>
-        <a:font script="Jpan" typeface="ＭＳ Ｐゴシック"/>
-        <a:font script="Hang" typeface="굴림"/>
-        <a:font script="Hans" typeface="黑体"/>
-        <a:font script="Hant" typeface="微軟正黑體"/>
-        <a:font script="Arab" typeface="Arial"/>
-        <a:font script="Hebr" typeface="Arial"/>
-        <a:font script="Thai" typeface="Cordia New"/>
-        <a:font script="Ethi" typeface="Nyala"/>
-        <a:font script="Beng" typeface="Vrinda"/>
-        <a:font script="Gujr" typeface="Shruti"/>
-        <a:font script="Khmr" typeface="DaunPenh"/>
-        <a:font script="Knda" typeface="Tunga"/>
-        <a:font script="Guru" typeface="Raavi"/>
-        <a:font script="Cans" typeface="Euphemia"/>
-        <a:font script="Cher" typeface="Plantagenet Cherokee"/>
-        <a:font script="Yiii" typeface="Microsoft Yi Baiti"/>
-        <a:font script="Tibt" typeface="Microsoft Himalaya"/>
-        <a:font script="Thaa" typeface="MV Boli"/>
-        <a:font script="Deva" typeface="Mangal"/>
-        <a:font script="Telu" typeface="Gautami"/>
-        <a:font script="Taml" typeface="Latha"/>
-        <a:font script="Syrc" typeface="Estrangelo Edessa"/>
-        <a:font script="Orya" typeface="Kalinga"/>
-        <a:font script="Mlym" typeface="Kartika"/>
-        <a:font script="Laoo" typeface="DokChampa"/>
-        <a:font script="Sinh" typeface="Iskoola Pota"/>
-        <a:font script="Mong" typeface="Mongolian Baiti"/>
-        <a:font script="Viet" typeface="Arial"/>
-        <a:font script="Uigh" typeface="Microsoft Uighur"/>
-        <a:font script="Geor" typeface="Sylfaen"/>
-      </a:majorFont>
-      <a:minorFont>
-        <a:latin typeface="Arial" panose="020B0604020202020204"/>
-        <a:ea typeface=""/>
-        <a:cs typeface=""/>
-        <a:font script="Jpan" typeface="ＭＳ Ｐゴシック"/>
-        <a:font script="Hang" typeface="굴림"/>
-        <a:font script="Hans" typeface="黑体"/>
-        <a:font script="Hant" typeface="微軟正黑體"/>
-        <a:font script="Arab" typeface="Arial"/>
-        <a:font script="Hebr" typeface="Arial"/>
-        <a:font script="Thai" typeface="Cordia New"/>
-        <a:font script="Ethi" typeface="Nyala"/>
-        <a:font script="Beng" typeface="Vrinda"/>
-        <a:font script="Gujr" typeface="Shruti"/>
-        <a:font script="Khmr" typeface="DaunPenh"/>
-        <a:font script="Knda" typeface="Tunga"/>
-        <a:font script="Guru" typeface="Raavi"/>
-        <a:font script="Cans" typeface="Euphemia"/>
-        <a:font script="Cher" typeface="Plantagenet Cherokee"/>
-        <a:font script="Yiii" typeface="Microsoft Yi Baiti"/>
-        <a:font script="Tibt" typeface="Microsoft Himalaya"/>
-        <a:font script="Thaa" typeface="MV Boli"/>
-        <a:font script="Deva" typeface="Mangal"/>
-        <a:font script="Telu" typeface="Gautami"/>
-        <a:font script="Taml" typeface="Latha"/>
-        <a:font script="Syrc" typeface="Estrangelo Edessa"/>
-        <a:font script="Orya" typeface="Kalinga"/>
-        <a:font script="Mlym" typeface="Kartika"/>
-        <a:font script="Laoo" typeface="DokChampa"/>
-        <a:font script="Sinh" typeface="Iskoola Pota"/>
-        <a:font script="Mong" typeface="Mongolian Baiti"/>
-        <a:font script="Viet" typeface="Arial"/>
-        <a:font script="Uigh" typeface="Microsoft Uighur"/>
-        <a:font script="Geor" typeface="Sylfaen"/>
-      </a:minorFont>
-    </a:fontScheme>
-    <a:fmtScheme name="Office">
-      <a:fillStyleLst>
-        <a:solidFill>
-          <a:schemeClr val="phClr"/>
-        </a:solidFill>
-        <a:gradFill rotWithShape="1">
-          <a:gsLst>
-            <a:gs pos="0">
-              <a:schemeClr val="phClr">
-                <a:lumMod val="110000"/>
-                <a:satMod val="105000"/>
-                <a:tint val="67000"/>
-              </a:schemeClr>
-            </a:gs>
-            <a:gs pos="50000">
-              <a:schemeClr val="phClr">
-                <a:lumMod val="105000"/>
-                <a:satMod val="103000"/>
-                <a:tint val="73000"/>
-              </a:schemeClr>
-            </a:gs>
-            <a:gs pos="100000">
-              <a:schemeClr val="phClr">
-                <a:lumMod val="105000"/>
-                <a:satMod val="109000"/>
-                <a:tint val="81000"/>
-              </a:schemeClr>
-            </a:gs>
-          </a:gsLst>
-          <a:lin ang="5400000" scaled="0"/>
-        </a:gradFill>
-        <a:gradFill rotWithShape="1">
-          <a:gsLst>
-            <a:gs pos="0">
-              <a:schemeClr val="phClr">
-                <a:satMod val="103000"/>
-                <a:lumMod val="102000"/>
-                <a:tint val="94000"/>
-              </a:schemeClr>
-            </a:gs>
-            <a:gs pos="50000">
-              <a:schemeClr val="phClr">
-                <a:satMod val="110000"/>
-                <a:lumMod val="100000"/>
-                <a:shade val="100000"/>
-              </a:schemeClr>
-            </a:gs>
-            <a:gs pos="100000">
-              <a:schemeClr val="phClr">
-                <a:lumMod val="99000"/>
-                <a:satMod val="120000"/>
-                <a:shade val="78000"/>
-              </a:schemeClr>
-            </a:gs>
-          </a:gsLst>
-          <a:lin ang="5400000" scaled="0"/>
-        </a:gradFill>
-      </a:fillStyleLst>
-      <a:lnStyleLst>
-        <a:ln w="6350" cap="flat" cmpd="sng" algn="ctr">
-          <a:solidFill>
-            <a:schemeClr val="phClr"/>
-          </a:solidFill>
-          <a:prstDash val="solid"/>
-          <a:miter lim="800000"/>
-        </a:ln>
-        <a:ln w="12700" cap="flat" cmpd="sng" algn="ctr">
-          <a:solidFill>
-            <a:schemeClr val="phClr"/>
-          </a:solidFill>
-          <a:prstDash val="solid"/>
-          <a:miter lim="800000"/>
-        </a:ln>
-        <a:ln w="19050" cap="flat" cmpd="sng" algn="ctr">
-          <a:solidFill>
-            <a:schemeClr val="phClr"/>
-          </a:solidFill>
-          <a:prstDash val="solid"/>
-          <a:miter lim="800000"/>
-        </a:ln>
-      </a:lnStyleLst>
-      <a:effectStyleLst>
-        <a:effectStyle>
-          <a:effectLst/>
-        </a:effectStyle>
-        <a:effectStyle>
-          <a:effectLst/>
-        </a:effectStyle>
-        <a:effectStyle>
-          <a:effectLst>
-            <a:outerShdw blurRad="57150" dist="19050" dir="5400000" algn="ctr" rotWithShape="0">
-              <a:srgbClr val="000000">
-                <a:alpha val="63000"/>
-              </a:srgbClr>
-            </a:outerShdw>
-          </a:effectLst>
-        </a:effectStyle>
-      </a:effectStyleLst>
-      <a:bgFillStyleLst>
-        <a:solidFill>
-          <a:schemeClr val="phClr"/>
-        </a:solidFill>
-        <a:solidFill>
-          <a:schemeClr val="phClr">
-            <a:tint val="95000"/>
-            <a:satMod val="170000"/>
-          </a:schemeClr>
-        </a:solidFill>
-        <a:gradFill rotWithShape="1">
-          <a:gsLst>
-            <a:gs pos="0">
-              <a:schemeClr val="phClr">
-                <a:tint val="93000"/>
-                <a:satMod val="150000"/>
-                <a:shade val="98000"/>
-                <a:lumMod val="102000"/>
-              </a:schemeClr>
-            </a:gs>
-            <a:gs pos="50000">
-              <a:schemeClr val="phClr">
-                <a:tint val="98000"/>
-                <a:satMod val="130000"/>
-                <a:shade val="90000"/>
-                <a:lumMod val="103000"/>
-              </a:schemeClr>
-            </a:gs>
-            <a:gs pos="100000">
-              <a:schemeClr val="phClr">
-                <a:shade val="63000"/>
-                <a:satMod val="120000"/>
-              </a:schemeClr>
-            </a:gs>
-          </a:gsLst>
-          <a:lin ang="5400000" scaled="0"/>
-        </a:gradFill>
-      </a:bgFillStyleLst>
-    </a:fmtScheme>
-  </a:themeElements>
-  <a:objectDefaults/>
-  <a:extraClrSchemeLst/>
-  <a:extLst>
-    <a:ext uri="{05A4C25C-085E-4340-85A3-A5531E510DB2}">
-      <thm15:themeFamily xmlns:thm15="http://schemas.microsoft.com/office/thememl/2012/main" name="SSE_Group_PowerPoint_Template use" id="{E4657FDB-B5CC-4A41-BF6D-183D81AD8D22}" vid="{1F5C7FD9-EB8F-2541-9465-A7ED68755437}"/>
-    </a:ext>
-  </a:extLst>
-</a:theme>
-</file>
-
-<file path=ppt/theme/theme3.xml><?xml version="1.0" encoding="utf-8"?>
-<a:theme xmlns:a="http://schemas.openxmlformats.org/drawingml/2006/main" name="Blank Slides">
-  <a:themeElements>
-    <a:clrScheme name="IFoA Colour Palette">
-      <a:dk1>
-        <a:srgbClr val="3F4548"/>
-      </a:dk1>
-      <a:lt1>
-        <a:srgbClr val="FEFFFF"/>
-      </a:lt1>
-      <a:dk2>
-        <a:srgbClr val="113458"/>
-      </a:dk2>
-      <a:lt2>
-        <a:srgbClr val="FCFDF8"/>
-      </a:lt2>
-      <a:accent1>
-        <a:srgbClr val="D9AB16"/>
-      </a:accent1>
-      <a:accent2>
-        <a:srgbClr val="D01E45"/>
-      </a:accent2>
-      <a:accent3>
-        <a:srgbClr val="EE741D"/>
-      </a:accent3>
-      <a:accent4>
-        <a:srgbClr val="11B3A2"/>
-      </a:accent4>
-      <a:accent5>
-        <a:srgbClr val="009CC8"/>
-      </a:accent5>
-      <a:accent6>
-        <a:srgbClr val="8F4693"/>
-      </a:accent6>
-      <a:hlink>
-        <a:srgbClr val="D9AB16"/>
-      </a:hlink>
-      <a:folHlink>
-        <a:srgbClr val="D9AB16"/>
       </a:folHlink>
     </a:clrScheme>
     <a:fontScheme name="Arial">

</xml_diff>

<commit_message>
Fix remaining pptx repair triggers: app.xml relationship type and duplicated spPr
Second diff against PowerPoint's repaired save showed (a) pandoc 3.1.2
writes the wrong relationship type for docProps/app.xml and (b) fix_pptx.py
missed pandoc's '<p:spPr />' spelling and added a second spPr element.
Both corrected in the post-render step.

Co-Authored-By: Claude Fable 5 <noreply@anthropic.com>
</commit_message>
<xml_diff>
--- a/presentations/ifoa/hwle_ifoa_life_2026.pptx
+++ b/presentations/ifoa/hwle_ifoa_life_2026.pptx
@@ -11780,7 +11780,6 @@
             <a:ext cx="14020800" cy="5659894"/>
           </a:xfrm>
         </p:spPr>
-        <p:spPr/>
         <p:txBody>
           <a:bodyPr wrap="square" rtlCol="0">
             <a:normAutofit/>
@@ -12025,7 +12024,6 @@
             <a:ext cx="14020800" cy="5659894"/>
           </a:xfrm>
         </p:spPr>
-        <p:spPr/>
         <p:txBody>
           <a:bodyPr wrap="square" rtlCol="0">
             <a:normAutofit/>
@@ -12247,7 +12245,6 @@
             <a:ext cx="14020800" cy="5659894"/>
           </a:xfrm>
         </p:spPr>
-        <p:spPr/>
         <p:txBody>
           <a:bodyPr wrap="square" rtlCol="0">
             <a:normAutofit/>
@@ -12620,7 +12617,6 @@
             <a:ext cx="14020800" cy="5659894"/>
           </a:xfrm>
         </p:spPr>
-        <p:spPr/>
         <p:txBody>
           <a:bodyPr wrap="square" rtlCol="0">
             <a:normAutofit/>
@@ -13113,7 +13109,6 @@
             <a:ext cx="14020800" cy="5659894"/>
           </a:xfrm>
         </p:spPr>
-        <p:spPr/>
         <p:txBody>
           <a:bodyPr wrap="square" rtlCol="0">
             <a:normAutofit/>
@@ -13365,7 +13360,6 @@
             <a:ext cx="6896104" cy="5459310"/>
           </a:xfrm>
         </p:spPr>
-        <p:spPr/>
         <p:txBody>
           <a:bodyPr wrap="square" rtlCol="0">
             <a:normAutofit/>
@@ -13448,7 +13442,6 @@
             <a:ext cx="6896104" cy="5459309"/>
           </a:xfrm>
         </p:spPr>
-        <p:spPr/>
         <p:txBody>
           <a:bodyPr wrap="square" rtlCol="0">
             <a:normAutofit/>
@@ -13633,7 +13626,6 @@
             <a:ext cx="14020800" cy="5659894"/>
           </a:xfrm>
         </p:spPr>
-        <p:spPr/>
         <p:txBody>
           <a:bodyPr wrap="square" rtlCol="0">
             <a:normAutofit/>
@@ -13988,7 +13980,6 @@
             <a:ext cx="14020800" cy="5659894"/>
           </a:xfrm>
         </p:spPr>
-        <p:spPr/>
         <p:txBody>
           <a:bodyPr wrap="square" rtlCol="0">
             <a:normAutofit/>
@@ -14438,7 +14429,6 @@
             <a:ext cx="6896104" cy="5459309"/>
           </a:xfrm>
         </p:spPr>
-        <p:spPr/>
         <p:txBody>
           <a:bodyPr wrap="square" rtlCol="0">
             <a:normAutofit/>
@@ -14681,7 +14671,6 @@
             <a:ext cx="7835897" cy="653900"/>
           </a:xfrm>
         </p:spPr>
-        <p:spPr/>
         <p:txBody>
           <a:bodyPr wrap="square" rtlCol="0">
             <a:normAutofit/>
@@ -15036,7 +15025,6 @@
             <a:ext cx="14020800" cy="5659894"/>
           </a:xfrm>
         </p:spPr>
-        <p:spPr/>
         <p:txBody>
           <a:bodyPr wrap="square" rtlCol="0">
             <a:normAutofit/>
@@ -15943,7 +15931,6 @@
             <a:ext cx="14020800" cy="5659894"/>
           </a:xfrm>
         </p:spPr>
-        <p:spPr/>
         <p:txBody>
           <a:bodyPr wrap="square" rtlCol="0">
             <a:normAutofit/>
@@ -16152,7 +16139,6 @@
             <a:ext cx="14020800" cy="5659894"/>
           </a:xfrm>
         </p:spPr>
-        <p:spPr/>
         <p:txBody>
           <a:bodyPr wrap="square" rtlCol="0">
             <a:normAutofit/>
@@ -16392,7 +16378,6 @@
             <a:ext cx="14020800" cy="5659894"/>
           </a:xfrm>
         </p:spPr>
-        <p:spPr/>
         <p:txBody>
           <a:bodyPr wrap="square" rtlCol="0">
             <a:normAutofit/>
@@ -16618,7 +16603,6 @@
             <a:ext cx="14020800" cy="5659894"/>
           </a:xfrm>
         </p:spPr>
-        <p:spPr/>
         <p:txBody>
           <a:bodyPr wrap="square" rtlCol="0">
             <a:normAutofit/>
@@ -16852,7 +16836,6 @@
             <a:ext cx="14020800" cy="5659894"/>
           </a:xfrm>
         </p:spPr>
-        <p:spPr/>
         <p:txBody>
           <a:bodyPr wrap="square" rtlCol="0">
             <a:normAutofit/>
@@ -17230,7 +17213,6 @@
             <a:ext cx="14020800" cy="5659894"/>
           </a:xfrm>
         </p:spPr>
-        <p:spPr/>
         <p:txBody>
           <a:bodyPr wrap="square" rtlCol="0">
             <a:normAutofit/>
@@ -17449,7 +17431,6 @@
             <a:ext cx="14020800" cy="5659894"/>
           </a:xfrm>
         </p:spPr>
-        <p:spPr/>
         <p:txBody>
           <a:bodyPr wrap="square" rtlCol="0">
             <a:normAutofit/>
@@ -17815,7 +17796,6 @@
             <a:ext cx="14020800" cy="5659894"/>
           </a:xfrm>
         </p:spPr>
-        <p:spPr/>
         <p:txBody>
           <a:bodyPr wrap="square" rtlCol="0">
             <a:normAutofit/>
@@ -18194,7 +18174,6 @@
             <a:ext cx="14020800" cy="5659894"/>
           </a:xfrm>
         </p:spPr>
-        <p:spPr/>
         <p:txBody>
           <a:bodyPr wrap="square" rtlCol="0">
             <a:normAutofit/>
@@ -19293,7 +19272,6 @@
             <a:ext cx="6896104" cy="5459310"/>
           </a:xfrm>
         </p:spPr>
-        <p:spPr/>
         <p:txBody>
           <a:bodyPr wrap="square" rtlCol="0">
             <a:normAutofit/>
@@ -19367,7 +19345,6 @@
             <a:ext cx="6896104" cy="5459309"/>
           </a:xfrm>
         </p:spPr>
-        <p:spPr/>
         <p:txBody>
           <a:bodyPr wrap="square" rtlCol="0">
             <a:normAutofit/>
@@ -19915,7 +19892,6 @@
             <a:ext cx="14020800" cy="5659894"/>
           </a:xfrm>
         </p:spPr>
-        <p:spPr/>
         <p:txBody>
           <a:bodyPr wrap="square" rtlCol="0">
             <a:normAutofit/>
@@ -21599,7 +21575,6 @@
             <a:ext cx="14020800" cy="5659894"/>
           </a:xfrm>
         </p:spPr>
-        <p:spPr/>
         <p:txBody>
           <a:bodyPr wrap="square" rtlCol="0">
             <a:normAutofit/>
@@ -22186,7 +22161,6 @@
             <a:ext cx="14020800" cy="5659894"/>
           </a:xfrm>
         </p:spPr>
-        <p:spPr/>
         <p:txBody>
           <a:bodyPr wrap="square" rtlCol="0">
             <a:normAutofit/>
@@ -22903,7 +22877,6 @@
             <a:ext cx="14020800" cy="5659894"/>
           </a:xfrm>
         </p:spPr>
-        <p:spPr/>
         <p:txBody>
           <a:bodyPr wrap="square" rtlCol="0">
             <a:normAutofit/>
@@ -23096,7 +23069,6 @@
             <a:ext cx="14020800" cy="5659894"/>
           </a:xfrm>
         </p:spPr>
-        <p:spPr/>
         <p:txBody>
           <a:bodyPr wrap="square" rtlCol="0">
             <a:normAutofit/>
@@ -23666,7 +23638,6 @@
             <a:ext cx="14020800" cy="5659894"/>
           </a:xfrm>
         </p:spPr>
-        <p:spPr/>
         <p:txBody>
           <a:bodyPr wrap="square" rtlCol="0">
             <a:normAutofit/>
@@ -24124,7 +24095,6 @@
             <a:ext cx="14020800" cy="5659894"/>
           </a:xfrm>
         </p:spPr>
-        <p:spPr/>
         <p:txBody>
           <a:bodyPr wrap="square" rtlCol="0">
             <a:normAutofit/>
@@ -24382,7 +24352,6 @@
             <a:ext cx="14020800" cy="5659894"/>
           </a:xfrm>
         </p:spPr>
-        <p:spPr/>
         <p:txBody>
           <a:bodyPr wrap="square" rtlCol="0">
             <a:normAutofit/>
@@ -24611,7 +24580,6 @@
             <a:ext cx="14020800" cy="5659894"/>
           </a:xfrm>
         </p:spPr>
-        <p:spPr/>
         <p:txBody>
           <a:bodyPr wrap="square" rtlCol="0">
             <a:normAutofit/>

</xml_diff>